<commit_message>
Restyle one-page insight PPTs: borders only, dark-red accents
Keep the original one-page layout; remove black header/footer fills
and teal/green fills. Use white panels with borders and dark-red
(#8B1A2B) accent lines for emphasis.

Co-authored-by: Annie <Annie-Summer@users.noreply.github.com>
</commit_message>
<xml_diff>
--- a/yunqi-2026-cipu-forum/docs/洞察一页-04-KVCache推理基础设施.pptx
+++ b/yunqi-2026-cipu-forum/docs/洞察一页-04-KVCache推理基础设施.pptx
@@ -3140,13 +3140,13 @@
         <p:spPr>
           <a:xfrm>
             <a:off x="0" y="0"/>
-            <a:ext cx="109728" cy="6858000"/>
+            <a:ext cx="50800" cy="6858000"/>
           </a:xfrm>
           <a:prstGeom prst="rect">
             <a:avLst/>
           </a:prstGeom>
           <a:solidFill>
-            <a:srgbClr val="0C6E6A"/>
+            <a:srgbClr val="8B1A2B"/>
           </a:solidFill>
           <a:ln>
             <a:noFill/>
@@ -3189,7 +3189,7 @@
             <a:avLst/>
           </a:prstGeom>
           <a:solidFill>
-            <a:srgbClr val="14283C"/>
+            <a:srgbClr val="FFFFFF"/>
           </a:solidFill>
           <a:ln>
             <a:noFill/>
@@ -3219,97 +3219,23 @@
       </p:sp>
       <p:sp>
         <p:nvSpPr>
-          <p:cNvPr id="5" name="TextBox 4"/>
-          <p:cNvSpPr txBox="1"/>
-          <p:nvPr/>
-        </p:nvSpPr>
-        <p:spPr>
-          <a:xfrm>
-            <a:off x="365760" y="146304"/>
-            <a:ext cx="11430000" cy="274320"/>
-          </a:xfrm>
-          <a:prstGeom prst="rect">
-            <a:avLst/>
-          </a:prstGeom>
-          <a:noFill/>
-        </p:spPr>
-        <p:txBody>
-          <a:bodyPr wrap="square">
-            <a:spAutoFit/>
-          </a:bodyPr>
-          <a:lstStyle/>
-          <a:p>
-            <a:pPr algn="l"/>
-            <a:r>
-              <a:rPr sz="1100" b="0">
-                <a:solidFill>
-                  <a:srgbClr val="9BC9C6"/>
-                </a:solidFill>
-                <a:latin typeface="Microsoft YaHei"/>
-                <a:ea typeface="Microsoft YaHei"/>
-              </a:rPr>
-              <a:t>04 · 王正恒 / 徐国强 · KVCache：从显存优化到软硬结合的推理基础设施</a:t>
-            </a:r>
-          </a:p>
-        </p:txBody>
-      </p:sp>
-      <p:sp>
-        <p:nvSpPr>
-          <p:cNvPr id="6" name="TextBox 5"/>
-          <p:cNvSpPr txBox="1"/>
-          <p:nvPr/>
-        </p:nvSpPr>
-        <p:spPr>
-          <a:xfrm>
-            <a:off x="365760" y="420624"/>
-            <a:ext cx="11430000" cy="502920"/>
-          </a:xfrm>
-          <a:prstGeom prst="rect">
-            <a:avLst/>
-          </a:prstGeom>
-          <a:noFill/>
-        </p:spPr>
-        <p:txBody>
-          <a:bodyPr wrap="square">
-            <a:spAutoFit/>
-          </a:bodyPr>
-          <a:lstStyle/>
-          <a:p>
-            <a:pPr algn="l"/>
-            <a:r>
-              <a:rPr sz="2000" b="1">
-                <a:solidFill>
-                  <a:srgbClr val="FFFFFF"/>
-                </a:solidFill>
-                <a:latin typeface="Microsoft YaHei"/>
-                <a:ea typeface="Microsoft YaHei"/>
-              </a:rPr>
-              <a:t>洞察：KVCache 已从框架技巧，升级为可调度的推理基础设施</a:t>
-            </a:r>
-          </a:p>
-        </p:txBody>
-      </p:sp>
-      <p:sp>
-        <p:nvSpPr>
-          <p:cNvPr id="7" name="Rectangle 6"/>
+          <p:cNvPr id="5" name="Rectangle 4"/>
           <p:cNvSpPr/>
           <p:nvPr/>
         </p:nvSpPr>
         <p:spPr>
           <a:xfrm>
-            <a:off x="320040" y="1207008"/>
-            <a:ext cx="11521440" cy="502920"/>
+            <a:off x="0" y="1026160"/>
+            <a:ext cx="12191695" cy="25400"/>
           </a:xfrm>
           <a:prstGeom prst="rect">
             <a:avLst/>
           </a:prstGeom>
           <a:solidFill>
-            <a:srgbClr val="E6F3F2"/>
+            <a:srgbClr val="8B1A2B"/>
           </a:solidFill>
-          <a:ln w="12700">
-            <a:solidFill>
-              <a:srgbClr val="0C6E6A"/>
-            </a:solidFill>
+          <a:ln>
+            <a:noFill/>
           </a:ln>
         </p:spPr>
         <p:style>
@@ -3336,14 +3262,14 @@
       </p:sp>
       <p:sp>
         <p:nvSpPr>
-          <p:cNvPr id="8" name="TextBox 7"/>
+          <p:cNvPr id="6" name="TextBox 5"/>
           <p:cNvSpPr txBox="1"/>
           <p:nvPr/>
         </p:nvSpPr>
         <p:spPr>
           <a:xfrm>
-            <a:off x="457200" y="1280160"/>
-            <a:ext cx="11247120" cy="384048"/>
+            <a:off x="365760" y="146304"/>
+            <a:ext cx="11430000" cy="274320"/>
           </a:xfrm>
           <a:prstGeom prst="rect">
             <a:avLst/>
@@ -3358,9 +3284,126 @@
           <a:p>
             <a:pPr algn="l"/>
             <a:r>
-              <a:rPr sz="1300" b="1">
-                <a:solidFill>
-                  <a:srgbClr val="0C6E6A"/>
+              <a:rPr sz="1300" b="0">
+                <a:solidFill>
+                  <a:srgbClr val="6B6B6B"/>
+                </a:solidFill>
+                <a:latin typeface="Microsoft YaHei"/>
+                <a:ea typeface="Microsoft YaHei"/>
+              </a:rPr>
+              <a:t>04 · 王正恒 / 徐国强 · KVCache：从显存优化到软硬结合的推理基础设施</a:t>
+            </a:r>
+          </a:p>
+        </p:txBody>
+      </p:sp>
+      <p:sp>
+        <p:nvSpPr>
+          <p:cNvPr id="7" name="TextBox 6"/>
+          <p:cNvSpPr txBox="1"/>
+          <p:nvPr/>
+        </p:nvSpPr>
+        <p:spPr>
+          <a:xfrm>
+            <a:off x="365760" y="420624"/>
+            <a:ext cx="11430000" cy="502920"/>
+          </a:xfrm>
+          <a:prstGeom prst="rect">
+            <a:avLst/>
+          </a:prstGeom>
+          <a:noFill/>
+        </p:spPr>
+        <p:txBody>
+          <a:bodyPr wrap="square">
+            <a:spAutoFit/>
+          </a:bodyPr>
+          <a:lstStyle/>
+          <a:p>
+            <a:pPr algn="l"/>
+            <a:r>
+              <a:rPr sz="2200" b="1">
+                <a:solidFill>
+                  <a:srgbClr val="1A1A1A"/>
+                </a:solidFill>
+                <a:latin typeface="Microsoft YaHei"/>
+                <a:ea typeface="Microsoft YaHei"/>
+              </a:rPr>
+              <a:t>洞察：KVCache 已从框架技巧，升级为可调度的推理基础设施</a:t>
+            </a:r>
+          </a:p>
+        </p:txBody>
+      </p:sp>
+      <p:sp>
+        <p:nvSpPr>
+          <p:cNvPr id="8" name="Rectangle 7"/>
+          <p:cNvSpPr/>
+          <p:nvPr/>
+        </p:nvSpPr>
+        <p:spPr>
+          <a:xfrm>
+            <a:off x="320040" y="1207008"/>
+            <a:ext cx="11521440" cy="502920"/>
+          </a:xfrm>
+          <a:prstGeom prst="rect">
+            <a:avLst/>
+          </a:prstGeom>
+          <a:solidFill>
+            <a:srgbClr val="FFFFFF"/>
+          </a:solidFill>
+          <a:ln w="19050">
+            <a:solidFill>
+              <a:srgbClr val="8B1A2B"/>
+            </a:solidFill>
+          </a:ln>
+        </p:spPr>
+        <p:style>
+          <a:lnRef idx="1">
+            <a:schemeClr val="accent1"/>
+          </a:lnRef>
+          <a:fillRef idx="3">
+            <a:schemeClr val="accent1"/>
+          </a:fillRef>
+          <a:effectRef idx="2">
+            <a:schemeClr val="accent1"/>
+          </a:effectRef>
+          <a:fontRef idx="minor">
+            <a:schemeClr val="lt1"/>
+          </a:fontRef>
+        </p:style>
+        <p:txBody>
+          <a:bodyPr rtlCol="0" anchor="ctr"/>
+          <a:lstStyle/>
+          <a:p>
+            <a:pPr algn="ctr"/>
+          </a:p>
+        </p:txBody>
+      </p:sp>
+      <p:sp>
+        <p:nvSpPr>
+          <p:cNvPr id="9" name="TextBox 8"/>
+          <p:cNvSpPr txBox="1"/>
+          <p:nvPr/>
+        </p:nvSpPr>
+        <p:spPr>
+          <a:xfrm>
+            <a:off x="457200" y="1298448"/>
+            <a:ext cx="11247120" cy="365760"/>
+          </a:xfrm>
+          <a:prstGeom prst="rect">
+            <a:avLst/>
+          </a:prstGeom>
+          <a:noFill/>
+        </p:spPr>
+        <p:txBody>
+          <a:bodyPr wrap="square">
+            <a:spAutoFit/>
+          </a:bodyPr>
+          <a:lstStyle/>
+          <a:p>
+            <a:pPr algn="l"/>
+            <a:r>
+              <a:rPr sz="1400" b="1">
+                <a:solidFill>
+                  <a:srgbClr val="1A1A1A"/>
                 </a:solidFill>
                 <a:latin typeface="Microsoft YaHei"/>
                 <a:ea typeface="Microsoft YaHei"/>
@@ -3372,7 +3415,7 @@
       </p:sp>
       <p:sp>
         <p:nvSpPr>
-          <p:cNvPr id="9" name="Rectangle 8"/>
+          <p:cNvPr id="10" name="Rectangle 9"/>
           <p:cNvSpPr/>
           <p:nvPr/>
         </p:nvSpPr>
@@ -3417,20 +3460,20 @@
       </p:sp>
       <p:sp>
         <p:nvSpPr>
-          <p:cNvPr id="10" name="Rectangle 9"/>
+          <p:cNvPr id="11" name="Rectangle 10"/>
           <p:cNvSpPr/>
           <p:nvPr/>
         </p:nvSpPr>
         <p:spPr>
           <a:xfrm>
             <a:off x="320040" y="1874519"/>
-            <a:ext cx="3703320" cy="384048"/>
+            <a:ext cx="3703320" cy="38100"/>
           </a:xfrm>
           <a:prstGeom prst="rect">
             <a:avLst/>
           </a:prstGeom>
           <a:solidFill>
-            <a:srgbClr val="0C6E6A"/>
+            <a:srgbClr val="8B1A2B"/>
           </a:solidFill>
           <a:ln>
             <a:noFill/>
@@ -3460,14 +3503,14 @@
       </p:sp>
       <p:sp>
         <p:nvSpPr>
-          <p:cNvPr id="11" name="TextBox 10"/>
+          <p:cNvPr id="12" name="TextBox 11"/>
           <p:cNvSpPr txBox="1"/>
           <p:nvPr/>
         </p:nvSpPr>
         <p:spPr>
           <a:xfrm>
-            <a:off x="457200" y="1947671"/>
-            <a:ext cx="3429000" cy="274320"/>
+            <a:off x="457200" y="2011679"/>
+            <a:ext cx="3429000" cy="320040"/>
           </a:xfrm>
           <a:prstGeom prst="rect">
             <a:avLst/>
@@ -3482,9 +3525,9 @@
           <a:p>
             <a:pPr algn="l"/>
             <a:r>
-              <a:rPr sz="1300" b="1">
-                <a:solidFill>
-                  <a:srgbClr val="FFFFFF"/>
+              <a:rPr sz="1600" b="1">
+                <a:solidFill>
+                  <a:srgbClr val="8B1A2B"/>
                 </a:solidFill>
                 <a:latin typeface="Microsoft YaHei"/>
                 <a:ea typeface="Microsoft YaHei"/>
@@ -3496,14 +3539,14 @@
       </p:sp>
       <p:sp>
         <p:nvSpPr>
-          <p:cNvPr id="12" name="TextBox 11"/>
+          <p:cNvPr id="13" name="TextBox 12"/>
           <p:cNvSpPr txBox="1"/>
           <p:nvPr/>
         </p:nvSpPr>
         <p:spPr>
           <a:xfrm>
-            <a:off x="484632" y="2350007"/>
-            <a:ext cx="3383280" cy="2057400"/>
+            <a:off x="484632" y="2377439"/>
+            <a:ext cx="3374136" cy="1965960"/>
           </a:xfrm>
           <a:prstGeom prst="rect">
             <a:avLst/>
@@ -3518,13 +3561,13 @@
           <a:p>
             <a:pPr algn="l">
               <a:spcAft>
-                <a:spcPts val="400"/>
+                <a:spcPts val="500"/>
               </a:spcAft>
             </a:pPr>
             <a:r>
-              <a:rPr sz="1100" b="1">
-                <a:solidFill>
-                  <a:srgbClr val="14283C"/>
+              <a:rPr sz="1300" b="1">
+                <a:solidFill>
+                  <a:srgbClr val="1A1A1A"/>
                 </a:solidFill>
                 <a:latin typeface="Microsoft YaHei"/>
                 <a:ea typeface="Microsoft YaHei"/>
@@ -3535,13 +3578,13 @@
           <a:p>
             <a:pPr algn="l">
               <a:spcAft>
-                <a:spcPts val="400"/>
+                <a:spcPts val="500"/>
               </a:spcAft>
             </a:pPr>
             <a:r>
-              <a:rPr sz="1100" b="0">
-                <a:solidFill>
-                  <a:srgbClr val="4A5B6A"/>
+              <a:rPr sz="1300" b="0">
+                <a:solidFill>
+                  <a:srgbClr val="4A4A4A"/>
                 </a:solidFill>
                 <a:latin typeface="Microsoft YaHei"/>
                 <a:ea typeface="Microsoft YaHei"/>
@@ -3552,13 +3595,13 @@
           <a:p>
             <a:pPr algn="l">
               <a:spcAft>
-                <a:spcPts val="400"/>
+                <a:spcPts val="500"/>
               </a:spcAft>
             </a:pPr>
             <a:r>
-              <a:rPr sz="1100" b="0">
-                <a:solidFill>
-                  <a:srgbClr val="4A5B6A"/>
+              <a:rPr sz="1300" b="0">
+                <a:solidFill>
+                  <a:srgbClr val="4A4A4A"/>
                 </a:solidFill>
                 <a:latin typeface="Microsoft YaHei"/>
                 <a:ea typeface="Microsoft YaHei"/>
@@ -3569,13 +3612,13 @@
           <a:p>
             <a:pPr algn="l">
               <a:spcAft>
-                <a:spcPts val="400"/>
+                <a:spcPts val="500"/>
               </a:spcAft>
             </a:pPr>
             <a:r>
-              <a:rPr sz="1100" b="0">
-                <a:solidFill>
-                  <a:srgbClr val="4A5B6A"/>
+              <a:rPr sz="1300" b="0">
+                <a:solidFill>
+                  <a:srgbClr val="4A4A4A"/>
                 </a:solidFill>
                 <a:latin typeface="Microsoft YaHei"/>
                 <a:ea typeface="Microsoft YaHei"/>
@@ -3586,13 +3629,13 @@
           <a:p>
             <a:pPr algn="l">
               <a:spcAft>
-                <a:spcPts val="400"/>
+                <a:spcPts val="500"/>
               </a:spcAft>
             </a:pPr>
             <a:r>
-              <a:rPr sz="1100" b="0">
-                <a:solidFill>
-                  <a:srgbClr val="4A5B6A"/>
+              <a:rPr sz="1300" b="0">
+                <a:solidFill>
+                  <a:srgbClr val="4A4A4A"/>
                 </a:solidFill>
                 <a:latin typeface="Microsoft YaHei"/>
                 <a:ea typeface="Microsoft YaHei"/>
@@ -3604,13 +3647,13 @@
       </p:sp>
       <p:sp>
         <p:nvSpPr>
-          <p:cNvPr id="13" name="Rectangle 12"/>
+          <p:cNvPr id="14" name="Rectangle 13"/>
           <p:cNvSpPr/>
           <p:nvPr/>
         </p:nvSpPr>
         <p:spPr>
           <a:xfrm>
-            <a:off x="4206240" y="1874519"/>
+            <a:off x="4224528" y="1874519"/>
             <a:ext cx="3703320" cy="2606040"/>
           </a:xfrm>
           <a:prstGeom prst="rect">
@@ -3649,20 +3692,20 @@
       </p:sp>
       <p:sp>
         <p:nvSpPr>
-          <p:cNvPr id="14" name="Rectangle 13"/>
+          <p:cNvPr id="15" name="Rectangle 14"/>
           <p:cNvSpPr/>
           <p:nvPr/>
         </p:nvSpPr>
         <p:spPr>
           <a:xfrm>
-            <a:off x="4206240" y="1874519"/>
-            <a:ext cx="3703320" cy="384048"/>
+            <a:off x="4224528" y="1874519"/>
+            <a:ext cx="3703320" cy="38100"/>
           </a:xfrm>
           <a:prstGeom prst="rect">
             <a:avLst/>
           </a:prstGeom>
           <a:solidFill>
-            <a:srgbClr val="0C6E6A"/>
+            <a:srgbClr val="8B1A2B"/>
           </a:solidFill>
           <a:ln>
             <a:noFill/>
@@ -3692,14 +3735,14 @@
       </p:sp>
       <p:sp>
         <p:nvSpPr>
-          <p:cNvPr id="15" name="TextBox 14"/>
+          <p:cNvPr id="16" name="TextBox 15"/>
           <p:cNvSpPr txBox="1"/>
           <p:nvPr/>
         </p:nvSpPr>
         <p:spPr>
           <a:xfrm>
-            <a:off x="4343400" y="1947671"/>
-            <a:ext cx="3429000" cy="274320"/>
+            <a:off x="4361688" y="2011679"/>
+            <a:ext cx="3429000" cy="320040"/>
           </a:xfrm>
           <a:prstGeom prst="rect">
             <a:avLst/>
@@ -3714,9 +3757,9 @@
           <a:p>
             <a:pPr algn="l"/>
             <a:r>
-              <a:rPr sz="1300" b="1">
-                <a:solidFill>
-                  <a:srgbClr val="FFFFFF"/>
+              <a:rPr sz="1600" b="1">
+                <a:solidFill>
+                  <a:srgbClr val="8B1A2B"/>
                 </a:solidFill>
                 <a:latin typeface="Microsoft YaHei"/>
                 <a:ea typeface="Microsoft YaHei"/>
@@ -3728,14 +3771,14 @@
       </p:sp>
       <p:sp>
         <p:nvSpPr>
-          <p:cNvPr id="16" name="TextBox 15"/>
+          <p:cNvPr id="17" name="TextBox 16"/>
           <p:cNvSpPr txBox="1"/>
           <p:nvPr/>
         </p:nvSpPr>
         <p:spPr>
           <a:xfrm>
-            <a:off x="4370832" y="2350007"/>
-            <a:ext cx="3383280" cy="2057400"/>
+            <a:off x="4389120" y="2377439"/>
+            <a:ext cx="3374136" cy="1965960"/>
           </a:xfrm>
           <a:prstGeom prst="rect">
             <a:avLst/>
@@ -3750,13 +3793,13 @@
           <a:p>
             <a:pPr algn="l">
               <a:spcAft>
-                <a:spcPts val="400"/>
+                <a:spcPts val="500"/>
               </a:spcAft>
             </a:pPr>
             <a:r>
-              <a:rPr sz="1100" b="1">
-                <a:solidFill>
-                  <a:srgbClr val="14283C"/>
+              <a:rPr sz="1300" b="1">
+                <a:solidFill>
+                  <a:srgbClr val="1A1A1A"/>
                 </a:solidFill>
                 <a:latin typeface="Microsoft YaHei"/>
                 <a:ea typeface="Microsoft YaHei"/>
@@ -3767,13 +3810,13 @@
           <a:p>
             <a:pPr algn="l">
               <a:spcAft>
-                <a:spcPts val="400"/>
+                <a:spcPts val="500"/>
               </a:spcAft>
             </a:pPr>
             <a:r>
-              <a:rPr sz="1100" b="0">
-                <a:solidFill>
-                  <a:srgbClr val="4A5B6A"/>
+              <a:rPr sz="1300" b="0">
+                <a:solidFill>
+                  <a:srgbClr val="4A4A4A"/>
                 </a:solidFill>
                 <a:latin typeface="Microsoft YaHei"/>
                 <a:ea typeface="Microsoft YaHei"/>
@@ -3784,13 +3827,13 @@
           <a:p>
             <a:pPr algn="l">
               <a:spcAft>
-                <a:spcPts val="400"/>
+                <a:spcPts val="500"/>
               </a:spcAft>
             </a:pPr>
             <a:r>
-              <a:rPr sz="1100" b="0">
-                <a:solidFill>
-                  <a:srgbClr val="4A5B6A"/>
+              <a:rPr sz="1300" b="0">
+                <a:solidFill>
+                  <a:srgbClr val="4A4A4A"/>
                 </a:solidFill>
                 <a:latin typeface="Microsoft YaHei"/>
                 <a:ea typeface="Microsoft YaHei"/>
@@ -3801,13 +3844,13 @@
           <a:p>
             <a:pPr algn="l">
               <a:spcAft>
-                <a:spcPts val="400"/>
+                <a:spcPts val="500"/>
               </a:spcAft>
             </a:pPr>
             <a:r>
-              <a:rPr sz="1100" b="0">
-                <a:solidFill>
-                  <a:srgbClr val="4A5B6A"/>
+              <a:rPr sz="1300" b="0">
+                <a:solidFill>
+                  <a:srgbClr val="4A4A4A"/>
                 </a:solidFill>
                 <a:latin typeface="Microsoft YaHei"/>
                 <a:ea typeface="Microsoft YaHei"/>
@@ -3818,13 +3861,13 @@
           <a:p>
             <a:pPr algn="l">
               <a:spcAft>
-                <a:spcPts val="400"/>
+                <a:spcPts val="500"/>
               </a:spcAft>
             </a:pPr>
             <a:r>
-              <a:rPr sz="1100" b="0">
-                <a:solidFill>
-                  <a:srgbClr val="4A5B6A"/>
+              <a:rPr sz="1300" b="0">
+                <a:solidFill>
+                  <a:srgbClr val="4A4A4A"/>
                 </a:solidFill>
                 <a:latin typeface="Microsoft YaHei"/>
                 <a:ea typeface="Microsoft YaHei"/>
@@ -3836,13 +3879,13 @@
       </p:sp>
       <p:sp>
         <p:nvSpPr>
-          <p:cNvPr id="17" name="Rectangle 16"/>
+          <p:cNvPr id="18" name="Rectangle 17"/>
           <p:cNvSpPr/>
           <p:nvPr/>
         </p:nvSpPr>
         <p:spPr>
           <a:xfrm>
-            <a:off x="8092440" y="1874519"/>
+            <a:off x="8129016" y="1874519"/>
             <a:ext cx="3703320" cy="2606040"/>
           </a:xfrm>
           <a:prstGeom prst="rect">
@@ -3881,20 +3924,20 @@
       </p:sp>
       <p:sp>
         <p:nvSpPr>
-          <p:cNvPr id="18" name="Rectangle 17"/>
+          <p:cNvPr id="19" name="Rectangle 18"/>
           <p:cNvSpPr/>
           <p:nvPr/>
         </p:nvSpPr>
         <p:spPr>
           <a:xfrm>
-            <a:off x="8092440" y="1874519"/>
-            <a:ext cx="3703320" cy="384048"/>
+            <a:off x="8129016" y="1874519"/>
+            <a:ext cx="3703320" cy="38100"/>
           </a:xfrm>
           <a:prstGeom prst="rect">
             <a:avLst/>
           </a:prstGeom>
           <a:solidFill>
-            <a:srgbClr val="0C6E6A"/>
+            <a:srgbClr val="8B1A2B"/>
           </a:solidFill>
           <a:ln>
             <a:noFill/>
@@ -3924,14 +3967,14 @@
       </p:sp>
       <p:sp>
         <p:nvSpPr>
-          <p:cNvPr id="19" name="TextBox 18"/>
+          <p:cNvPr id="20" name="TextBox 19"/>
           <p:cNvSpPr txBox="1"/>
           <p:nvPr/>
         </p:nvSpPr>
         <p:spPr>
           <a:xfrm>
-            <a:off x="8229600" y="1947671"/>
-            <a:ext cx="3429000" cy="274320"/>
+            <a:off x="8266176" y="2011679"/>
+            <a:ext cx="3429000" cy="320040"/>
           </a:xfrm>
           <a:prstGeom prst="rect">
             <a:avLst/>
@@ -3946,9 +3989,9 @@
           <a:p>
             <a:pPr algn="l"/>
             <a:r>
-              <a:rPr sz="1300" b="1">
-                <a:solidFill>
-                  <a:srgbClr val="FFFFFF"/>
+              <a:rPr sz="1600" b="1">
+                <a:solidFill>
+                  <a:srgbClr val="8B1A2B"/>
                 </a:solidFill>
                 <a:latin typeface="Microsoft YaHei"/>
                 <a:ea typeface="Microsoft YaHei"/>
@@ -3960,14 +4003,14 @@
       </p:sp>
       <p:sp>
         <p:nvSpPr>
-          <p:cNvPr id="20" name="TextBox 19"/>
+          <p:cNvPr id="21" name="TextBox 20"/>
           <p:cNvSpPr txBox="1"/>
           <p:nvPr/>
         </p:nvSpPr>
         <p:spPr>
           <a:xfrm>
-            <a:off x="8257032" y="2350007"/>
-            <a:ext cx="3383280" cy="2057400"/>
+            <a:off x="8293608" y="2377439"/>
+            <a:ext cx="3374136" cy="1965960"/>
           </a:xfrm>
           <a:prstGeom prst="rect">
             <a:avLst/>
@@ -3982,13 +4025,13 @@
           <a:p>
             <a:pPr algn="l">
               <a:spcAft>
-                <a:spcPts val="400"/>
+                <a:spcPts val="500"/>
               </a:spcAft>
             </a:pPr>
             <a:r>
-              <a:rPr sz="1100" b="1">
-                <a:solidFill>
-                  <a:srgbClr val="14283C"/>
+              <a:rPr sz="1300" b="1">
+                <a:solidFill>
+                  <a:srgbClr val="1A1A1A"/>
                 </a:solidFill>
                 <a:latin typeface="Microsoft YaHei"/>
                 <a:ea typeface="Microsoft YaHei"/>
@@ -3999,13 +4042,13 @@
           <a:p>
             <a:pPr algn="l">
               <a:spcAft>
-                <a:spcPts val="400"/>
+                <a:spcPts val="500"/>
               </a:spcAft>
             </a:pPr>
             <a:r>
-              <a:rPr sz="1100" b="0">
-                <a:solidFill>
-                  <a:srgbClr val="4A5B6A"/>
+              <a:rPr sz="1300" b="0">
+                <a:solidFill>
+                  <a:srgbClr val="4A4A4A"/>
                 </a:solidFill>
                 <a:latin typeface="Microsoft YaHei"/>
                 <a:ea typeface="Microsoft YaHei"/>
@@ -4016,13 +4059,13 @@
           <a:p>
             <a:pPr algn="l">
               <a:spcAft>
-                <a:spcPts val="400"/>
+                <a:spcPts val="500"/>
               </a:spcAft>
             </a:pPr>
             <a:r>
-              <a:rPr sz="1100" b="0">
-                <a:solidFill>
-                  <a:srgbClr val="4A5B6A"/>
+              <a:rPr sz="1300" b="0">
+                <a:solidFill>
+                  <a:srgbClr val="4A4A4A"/>
                 </a:solidFill>
                 <a:latin typeface="Microsoft YaHei"/>
                 <a:ea typeface="Microsoft YaHei"/>
@@ -4033,13 +4076,13 @@
           <a:p>
             <a:pPr algn="l">
               <a:spcAft>
-                <a:spcPts val="400"/>
+                <a:spcPts val="500"/>
               </a:spcAft>
             </a:pPr>
             <a:r>
-              <a:rPr sz="1100" b="0">
-                <a:solidFill>
-                  <a:srgbClr val="4A5B6A"/>
+              <a:rPr sz="1300" b="0">
+                <a:solidFill>
+                  <a:srgbClr val="4A4A4A"/>
                 </a:solidFill>
                 <a:latin typeface="Microsoft YaHei"/>
                 <a:ea typeface="Microsoft YaHei"/>
@@ -4050,13 +4093,13 @@
           <a:p>
             <a:pPr algn="l">
               <a:spcAft>
-                <a:spcPts val="400"/>
+                <a:spcPts val="500"/>
               </a:spcAft>
             </a:pPr>
             <a:r>
-              <a:rPr sz="1100" b="0">
-                <a:solidFill>
-                  <a:srgbClr val="4A5B6A"/>
+              <a:rPr sz="1300" b="0">
+                <a:solidFill>
+                  <a:srgbClr val="4A4A4A"/>
                 </a:solidFill>
                 <a:latin typeface="Microsoft YaHei"/>
                 <a:ea typeface="Microsoft YaHei"/>
@@ -4068,13 +4111,13 @@
       </p:sp>
       <p:sp>
         <p:nvSpPr>
-          <p:cNvPr id="21" name="TextBox 20"/>
+          <p:cNvPr id="22" name="TextBox 21"/>
           <p:cNvSpPr txBox="1"/>
           <p:nvPr/>
         </p:nvSpPr>
         <p:spPr>
           <a:xfrm>
-            <a:off x="320040" y="4663440"/>
+            <a:off x="320040" y="4617720"/>
             <a:ext cx="7315200" cy="256032"/>
           </a:xfrm>
           <a:prstGeom prst="rect">
@@ -4090,9 +4133,9 @@
           <a:p>
             <a:pPr algn="l"/>
             <a:r>
-              <a:rPr sz="1200" b="1">
-                <a:solidFill>
-                  <a:srgbClr val="14283C"/>
+              <a:rPr sz="1400" b="1">
+                <a:solidFill>
+                  <a:srgbClr val="1A1A1A"/>
                 </a:solidFill>
                 <a:latin typeface="Microsoft YaHei"/>
                 <a:ea typeface="Microsoft YaHei"/>
@@ -4104,14 +4147,14 @@
       </p:sp>
       <p:sp>
         <p:nvSpPr>
-          <p:cNvPr id="22" name="Rectangle 21"/>
+          <p:cNvPr id="23" name="Rectangle 22"/>
           <p:cNvSpPr/>
           <p:nvPr/>
         </p:nvSpPr>
         <p:spPr>
           <a:xfrm>
-            <a:off x="320040" y="4937760"/>
-            <a:ext cx="1844040" cy="868680"/>
+            <a:off x="320040" y="4910328"/>
+            <a:ext cx="1847088" cy="868680"/>
           </a:xfrm>
           <a:prstGeom prst="rect">
             <a:avLst/>
@@ -4149,20 +4192,20 @@
       </p:sp>
       <p:sp>
         <p:nvSpPr>
-          <p:cNvPr id="23" name="Rectangle 22"/>
+          <p:cNvPr id="24" name="Rectangle 23"/>
           <p:cNvSpPr/>
           <p:nvPr/>
         </p:nvSpPr>
         <p:spPr>
           <a:xfrm>
-            <a:off x="320040" y="4937760"/>
-            <a:ext cx="73152" cy="868680"/>
+            <a:off x="320040" y="4910328"/>
+            <a:ext cx="50800" cy="868680"/>
           </a:xfrm>
           <a:prstGeom prst="rect">
             <a:avLst/>
           </a:prstGeom>
           <a:solidFill>
-            <a:srgbClr val="C45C26"/>
+            <a:srgbClr val="8B1A2B"/>
           </a:solidFill>
           <a:ln>
             <a:noFill/>
@@ -4192,14 +4235,14 @@
       </p:sp>
       <p:sp>
         <p:nvSpPr>
-          <p:cNvPr id="24" name="TextBox 23"/>
+          <p:cNvPr id="25" name="TextBox 24"/>
           <p:cNvSpPr txBox="1"/>
           <p:nvPr/>
         </p:nvSpPr>
         <p:spPr>
           <a:xfrm>
-            <a:off x="466344" y="4992624"/>
-            <a:ext cx="1642872" cy="201168"/>
+            <a:off x="466344" y="4965192"/>
+            <a:ext cx="1645920" cy="201168"/>
           </a:xfrm>
           <a:prstGeom prst="rect">
             <a:avLst/>
@@ -4214,9 +4257,9 @@
           <a:p>
             <a:pPr algn="l"/>
             <a:r>
-              <a:rPr sz="900" b="0">
-                <a:solidFill>
-                  <a:srgbClr val="4A5B6A"/>
+              <a:rPr sz="1100" b="0">
+                <a:solidFill>
+                  <a:srgbClr val="6B6B6B"/>
                 </a:solidFill>
                 <a:latin typeface="Microsoft YaHei"/>
                 <a:ea typeface="Microsoft YaHei"/>
@@ -4228,14 +4271,14 @@
       </p:sp>
       <p:sp>
         <p:nvSpPr>
-          <p:cNvPr id="25" name="TextBox 24"/>
+          <p:cNvPr id="26" name="TextBox 25"/>
           <p:cNvSpPr txBox="1"/>
           <p:nvPr/>
         </p:nvSpPr>
         <p:spPr>
           <a:xfrm>
-            <a:off x="466344" y="5193792"/>
-            <a:ext cx="1642872" cy="256032"/>
+            <a:off x="466344" y="5166360"/>
+            <a:ext cx="1645920" cy="256032"/>
           </a:xfrm>
           <a:prstGeom prst="rect">
             <a:avLst/>
@@ -4250,9 +4293,9 @@
           <a:p>
             <a:pPr algn="l"/>
             <a:r>
-              <a:rPr sz="1100" b="1">
-                <a:solidFill>
-                  <a:srgbClr val="14283C"/>
+              <a:rPr sz="1100" b="0">
+                <a:solidFill>
+                  <a:srgbClr val="4A4A4A"/>
                 </a:solidFill>
                 <a:latin typeface="Microsoft YaHei"/>
                 <a:ea typeface="Microsoft YaHei"/>
@@ -4264,14 +4307,14 @@
       </p:sp>
       <p:sp>
         <p:nvSpPr>
-          <p:cNvPr id="26" name="TextBox 25"/>
+          <p:cNvPr id="27" name="TextBox 26"/>
           <p:cNvSpPr txBox="1"/>
           <p:nvPr/>
         </p:nvSpPr>
         <p:spPr>
           <a:xfrm>
-            <a:off x="466344" y="5449824"/>
-            <a:ext cx="1642872" cy="256032"/>
+            <a:off x="466344" y="5413248"/>
+            <a:ext cx="1645920" cy="292608"/>
           </a:xfrm>
           <a:prstGeom prst="rect">
             <a:avLst/>
@@ -4286,9 +4329,9 @@
           <a:p>
             <a:pPr algn="l"/>
             <a:r>
-              <a:rPr sz="1300" b="1">
-                <a:solidFill>
-                  <a:srgbClr val="C45C26"/>
+              <a:rPr sz="1800" b="1">
+                <a:solidFill>
+                  <a:srgbClr val="8B1A2B"/>
                 </a:solidFill>
                 <a:latin typeface="Microsoft YaHei"/>
                 <a:ea typeface="Microsoft YaHei"/>
@@ -4300,14 +4343,14 @@
       </p:sp>
       <p:sp>
         <p:nvSpPr>
-          <p:cNvPr id="27" name="Rectangle 26"/>
+          <p:cNvPr id="28" name="Rectangle 27"/>
           <p:cNvSpPr/>
           <p:nvPr/>
         </p:nvSpPr>
         <p:spPr>
           <a:xfrm>
-            <a:off x="2255520" y="4937760"/>
-            <a:ext cx="1844040" cy="868680"/>
+            <a:off x="2276856" y="4910328"/>
+            <a:ext cx="1847088" cy="868680"/>
           </a:xfrm>
           <a:prstGeom prst="rect">
             <a:avLst/>
@@ -4345,20 +4388,20 @@
       </p:sp>
       <p:sp>
         <p:nvSpPr>
-          <p:cNvPr id="28" name="Rectangle 27"/>
+          <p:cNvPr id="29" name="Rectangle 28"/>
           <p:cNvSpPr/>
           <p:nvPr/>
         </p:nvSpPr>
         <p:spPr>
           <a:xfrm>
-            <a:off x="2255520" y="4937760"/>
-            <a:ext cx="73152" cy="868680"/>
+            <a:off x="2276856" y="4910328"/>
+            <a:ext cx="50800" cy="868680"/>
           </a:xfrm>
           <a:prstGeom prst="rect">
             <a:avLst/>
           </a:prstGeom>
           <a:solidFill>
-            <a:srgbClr val="C45C26"/>
+            <a:srgbClr val="8B1A2B"/>
           </a:solidFill>
           <a:ln>
             <a:noFill/>
@@ -4388,14 +4431,14 @@
       </p:sp>
       <p:sp>
         <p:nvSpPr>
-          <p:cNvPr id="29" name="TextBox 28"/>
+          <p:cNvPr id="30" name="TextBox 29"/>
           <p:cNvSpPr txBox="1"/>
           <p:nvPr/>
         </p:nvSpPr>
         <p:spPr>
           <a:xfrm>
-            <a:off x="2401824" y="4992624"/>
-            <a:ext cx="1642872" cy="201168"/>
+            <a:off x="2423160" y="4965192"/>
+            <a:ext cx="1645920" cy="201168"/>
           </a:xfrm>
           <a:prstGeom prst="rect">
             <a:avLst/>
@@ -4410,9 +4453,9 @@
           <a:p>
             <a:pPr algn="l"/>
             <a:r>
-              <a:rPr sz="900" b="0">
-                <a:solidFill>
-                  <a:srgbClr val="4A5B6A"/>
+              <a:rPr sz="1100" b="0">
+                <a:solidFill>
+                  <a:srgbClr val="6B6B6B"/>
                 </a:solidFill>
                 <a:latin typeface="Microsoft YaHei"/>
                 <a:ea typeface="Microsoft YaHei"/>
@@ -4424,14 +4467,14 @@
       </p:sp>
       <p:sp>
         <p:nvSpPr>
-          <p:cNvPr id="30" name="TextBox 29"/>
+          <p:cNvPr id="31" name="TextBox 30"/>
           <p:cNvSpPr txBox="1"/>
           <p:nvPr/>
         </p:nvSpPr>
         <p:spPr>
           <a:xfrm>
-            <a:off x="2401824" y="5193792"/>
-            <a:ext cx="1642872" cy="256032"/>
+            <a:off x="2423160" y="5166360"/>
+            <a:ext cx="1645920" cy="256032"/>
           </a:xfrm>
           <a:prstGeom prst="rect">
             <a:avLst/>
@@ -4446,9 +4489,9 @@
           <a:p>
             <a:pPr algn="l"/>
             <a:r>
-              <a:rPr sz="1100" b="1">
-                <a:solidFill>
-                  <a:srgbClr val="14283C"/>
+              <a:rPr sz="1100" b="0">
+                <a:solidFill>
+                  <a:srgbClr val="4A4A4A"/>
                 </a:solidFill>
                 <a:latin typeface="Microsoft YaHei"/>
                 <a:ea typeface="Microsoft YaHei"/>
@@ -4460,14 +4503,14 @@
       </p:sp>
       <p:sp>
         <p:nvSpPr>
-          <p:cNvPr id="31" name="TextBox 30"/>
+          <p:cNvPr id="32" name="TextBox 31"/>
           <p:cNvSpPr txBox="1"/>
           <p:nvPr/>
         </p:nvSpPr>
         <p:spPr>
           <a:xfrm>
-            <a:off x="2401824" y="5449824"/>
-            <a:ext cx="1642872" cy="256032"/>
+            <a:off x="2423160" y="5413248"/>
+            <a:ext cx="1645920" cy="292608"/>
           </a:xfrm>
           <a:prstGeom prst="rect">
             <a:avLst/>
@@ -4482,9 +4525,9 @@
           <a:p>
             <a:pPr algn="l"/>
             <a:r>
-              <a:rPr sz="1300" b="1">
-                <a:solidFill>
-                  <a:srgbClr val="C45C26"/>
+              <a:rPr sz="1800" b="1">
+                <a:solidFill>
+                  <a:srgbClr val="8B1A2B"/>
                 </a:solidFill>
                 <a:latin typeface="Microsoft YaHei"/>
                 <a:ea typeface="Microsoft YaHei"/>
@@ -4496,14 +4539,14 @@
       </p:sp>
       <p:sp>
         <p:nvSpPr>
-          <p:cNvPr id="32" name="Rectangle 31"/>
+          <p:cNvPr id="33" name="Rectangle 32"/>
           <p:cNvSpPr/>
           <p:nvPr/>
         </p:nvSpPr>
         <p:spPr>
           <a:xfrm>
-            <a:off x="4191000" y="4937760"/>
-            <a:ext cx="1844040" cy="868680"/>
+            <a:off x="4233672" y="4910328"/>
+            <a:ext cx="1847088" cy="868680"/>
           </a:xfrm>
           <a:prstGeom prst="rect">
             <a:avLst/>
@@ -4541,20 +4584,20 @@
       </p:sp>
       <p:sp>
         <p:nvSpPr>
-          <p:cNvPr id="33" name="Rectangle 32"/>
+          <p:cNvPr id="34" name="Rectangle 33"/>
           <p:cNvSpPr/>
           <p:nvPr/>
         </p:nvSpPr>
         <p:spPr>
           <a:xfrm>
-            <a:off x="4191000" y="4937760"/>
-            <a:ext cx="73152" cy="868680"/>
+            <a:off x="4233672" y="4910328"/>
+            <a:ext cx="50800" cy="868680"/>
           </a:xfrm>
           <a:prstGeom prst="rect">
             <a:avLst/>
           </a:prstGeom>
           <a:solidFill>
-            <a:srgbClr val="C45C26"/>
+            <a:srgbClr val="8B1A2B"/>
           </a:solidFill>
           <a:ln>
             <a:noFill/>
@@ -4584,14 +4627,14 @@
       </p:sp>
       <p:sp>
         <p:nvSpPr>
-          <p:cNvPr id="34" name="TextBox 33"/>
+          <p:cNvPr id="35" name="TextBox 34"/>
           <p:cNvSpPr txBox="1"/>
           <p:nvPr/>
         </p:nvSpPr>
         <p:spPr>
           <a:xfrm>
-            <a:off x="4337304" y="4992624"/>
-            <a:ext cx="1642872" cy="201168"/>
+            <a:off x="4379976" y="4965192"/>
+            <a:ext cx="1645920" cy="201168"/>
           </a:xfrm>
           <a:prstGeom prst="rect">
             <a:avLst/>
@@ -4606,9 +4649,9 @@
           <a:p>
             <a:pPr algn="l"/>
             <a:r>
-              <a:rPr sz="900" b="0">
-                <a:solidFill>
-                  <a:srgbClr val="4A5B6A"/>
+              <a:rPr sz="1100" b="0">
+                <a:solidFill>
+                  <a:srgbClr val="6B6B6B"/>
                 </a:solidFill>
                 <a:latin typeface="Microsoft YaHei"/>
                 <a:ea typeface="Microsoft YaHei"/>
@@ -4620,14 +4663,14 @@
       </p:sp>
       <p:sp>
         <p:nvSpPr>
-          <p:cNvPr id="35" name="TextBox 34"/>
+          <p:cNvPr id="36" name="TextBox 35"/>
           <p:cNvSpPr txBox="1"/>
           <p:nvPr/>
         </p:nvSpPr>
         <p:spPr>
           <a:xfrm>
-            <a:off x="4337304" y="5193792"/>
-            <a:ext cx="1642872" cy="256032"/>
+            <a:off x="4379976" y="5166360"/>
+            <a:ext cx="1645920" cy="256032"/>
           </a:xfrm>
           <a:prstGeom prst="rect">
             <a:avLst/>
@@ -4642,9 +4685,9 @@
           <a:p>
             <a:pPr algn="l"/>
             <a:r>
-              <a:rPr sz="1100" b="1">
-                <a:solidFill>
-                  <a:srgbClr val="14283C"/>
+              <a:rPr sz="1100" b="0">
+                <a:solidFill>
+                  <a:srgbClr val="4A4A4A"/>
                 </a:solidFill>
                 <a:latin typeface="Microsoft YaHei"/>
                 <a:ea typeface="Microsoft YaHei"/>
@@ -4656,14 +4699,14 @@
       </p:sp>
       <p:sp>
         <p:nvSpPr>
-          <p:cNvPr id="36" name="TextBox 35"/>
+          <p:cNvPr id="37" name="TextBox 36"/>
           <p:cNvSpPr txBox="1"/>
           <p:nvPr/>
         </p:nvSpPr>
         <p:spPr>
           <a:xfrm>
-            <a:off x="4337304" y="5449824"/>
-            <a:ext cx="1642872" cy="256032"/>
+            <a:off x="4379976" y="5413248"/>
+            <a:ext cx="1645920" cy="292608"/>
           </a:xfrm>
           <a:prstGeom prst="rect">
             <a:avLst/>
@@ -4678,9 +4721,9 @@
           <a:p>
             <a:pPr algn="l"/>
             <a:r>
-              <a:rPr sz="1300" b="1">
-                <a:solidFill>
-                  <a:srgbClr val="C45C26"/>
+              <a:rPr sz="1800" b="1">
+                <a:solidFill>
+                  <a:srgbClr val="8B1A2B"/>
                 </a:solidFill>
                 <a:latin typeface="Microsoft YaHei"/>
                 <a:ea typeface="Microsoft YaHei"/>
@@ -4692,14 +4735,14 @@
       </p:sp>
       <p:sp>
         <p:nvSpPr>
-          <p:cNvPr id="37" name="Rectangle 36"/>
+          <p:cNvPr id="38" name="Rectangle 37"/>
           <p:cNvSpPr/>
           <p:nvPr/>
         </p:nvSpPr>
         <p:spPr>
           <a:xfrm>
-            <a:off x="6126480" y="4937760"/>
-            <a:ext cx="1844040" cy="868680"/>
+            <a:off x="6190488" y="4910328"/>
+            <a:ext cx="1847088" cy="868680"/>
           </a:xfrm>
           <a:prstGeom prst="rect">
             <a:avLst/>
@@ -4737,20 +4780,20 @@
       </p:sp>
       <p:sp>
         <p:nvSpPr>
-          <p:cNvPr id="38" name="Rectangle 37"/>
+          <p:cNvPr id="39" name="Rectangle 38"/>
           <p:cNvSpPr/>
           <p:nvPr/>
         </p:nvSpPr>
         <p:spPr>
           <a:xfrm>
-            <a:off x="6126480" y="4937760"/>
-            <a:ext cx="73152" cy="868680"/>
+            <a:off x="6190488" y="4910328"/>
+            <a:ext cx="50800" cy="868680"/>
           </a:xfrm>
           <a:prstGeom prst="rect">
             <a:avLst/>
           </a:prstGeom>
           <a:solidFill>
-            <a:srgbClr val="C45C26"/>
+            <a:srgbClr val="8B1A2B"/>
           </a:solidFill>
           <a:ln>
             <a:noFill/>
@@ -4780,14 +4823,14 @@
       </p:sp>
       <p:sp>
         <p:nvSpPr>
-          <p:cNvPr id="39" name="TextBox 38"/>
+          <p:cNvPr id="40" name="TextBox 39"/>
           <p:cNvSpPr txBox="1"/>
           <p:nvPr/>
         </p:nvSpPr>
         <p:spPr>
           <a:xfrm>
-            <a:off x="6272784" y="4992624"/>
-            <a:ext cx="1642872" cy="201168"/>
+            <a:off x="6336792" y="4965192"/>
+            <a:ext cx="1645920" cy="201168"/>
           </a:xfrm>
           <a:prstGeom prst="rect">
             <a:avLst/>
@@ -4802,9 +4845,9 @@
           <a:p>
             <a:pPr algn="l"/>
             <a:r>
-              <a:rPr sz="900" b="0">
-                <a:solidFill>
-                  <a:srgbClr val="4A5B6A"/>
+              <a:rPr sz="1100" b="0">
+                <a:solidFill>
+                  <a:srgbClr val="6B6B6B"/>
                 </a:solidFill>
                 <a:latin typeface="Microsoft YaHei"/>
                 <a:ea typeface="Microsoft YaHei"/>
@@ -4816,14 +4859,14 @@
       </p:sp>
       <p:sp>
         <p:nvSpPr>
-          <p:cNvPr id="40" name="TextBox 39"/>
+          <p:cNvPr id="41" name="TextBox 40"/>
           <p:cNvSpPr txBox="1"/>
           <p:nvPr/>
         </p:nvSpPr>
         <p:spPr>
           <a:xfrm>
-            <a:off x="6272784" y="5193792"/>
-            <a:ext cx="1642872" cy="256032"/>
+            <a:off x="6336792" y="5166360"/>
+            <a:ext cx="1645920" cy="256032"/>
           </a:xfrm>
           <a:prstGeom prst="rect">
             <a:avLst/>
@@ -4838,9 +4881,9 @@
           <a:p>
             <a:pPr algn="l"/>
             <a:r>
-              <a:rPr sz="1100" b="1">
-                <a:solidFill>
-                  <a:srgbClr val="14283C"/>
+              <a:rPr sz="1100" b="0">
+                <a:solidFill>
+                  <a:srgbClr val="4A4A4A"/>
                 </a:solidFill>
                 <a:latin typeface="Microsoft YaHei"/>
                 <a:ea typeface="Microsoft YaHei"/>
@@ -4852,14 +4895,14 @@
       </p:sp>
       <p:sp>
         <p:nvSpPr>
-          <p:cNvPr id="41" name="TextBox 40"/>
+          <p:cNvPr id="42" name="TextBox 41"/>
           <p:cNvSpPr txBox="1"/>
           <p:nvPr/>
         </p:nvSpPr>
         <p:spPr>
           <a:xfrm>
-            <a:off x="6272784" y="5449824"/>
-            <a:ext cx="1642872" cy="256032"/>
+            <a:off x="6336792" y="5413248"/>
+            <a:ext cx="1645920" cy="292608"/>
           </a:xfrm>
           <a:prstGeom prst="rect">
             <a:avLst/>
@@ -4874,9 +4917,9 @@
           <a:p>
             <a:pPr algn="l"/>
             <a:r>
-              <a:rPr sz="1300" b="1">
-                <a:solidFill>
-                  <a:srgbClr val="C45C26"/>
+              <a:rPr sz="1800" b="1">
+                <a:solidFill>
+                  <a:srgbClr val="8B1A2B"/>
                 </a:solidFill>
                 <a:latin typeface="Microsoft YaHei"/>
                 <a:ea typeface="Microsoft YaHei"/>
@@ -4888,14 +4931,14 @@
       </p:sp>
       <p:sp>
         <p:nvSpPr>
-          <p:cNvPr id="42" name="Rectangle 41"/>
+          <p:cNvPr id="43" name="Rectangle 42"/>
           <p:cNvSpPr/>
           <p:nvPr/>
         </p:nvSpPr>
         <p:spPr>
           <a:xfrm>
-            <a:off x="8061960" y="4937760"/>
-            <a:ext cx="1844040" cy="868680"/>
+            <a:off x="8147304" y="4910328"/>
+            <a:ext cx="1847088" cy="868680"/>
           </a:xfrm>
           <a:prstGeom prst="rect">
             <a:avLst/>
@@ -4933,20 +4976,20 @@
       </p:sp>
       <p:sp>
         <p:nvSpPr>
-          <p:cNvPr id="43" name="Rectangle 42"/>
+          <p:cNvPr id="44" name="Rectangle 43"/>
           <p:cNvSpPr/>
           <p:nvPr/>
         </p:nvSpPr>
         <p:spPr>
           <a:xfrm>
-            <a:off x="8061960" y="4937760"/>
-            <a:ext cx="73152" cy="868680"/>
+            <a:off x="8147304" y="4910328"/>
+            <a:ext cx="50800" cy="868680"/>
           </a:xfrm>
           <a:prstGeom prst="rect">
             <a:avLst/>
           </a:prstGeom>
           <a:solidFill>
-            <a:srgbClr val="C45C26"/>
+            <a:srgbClr val="8B1A2B"/>
           </a:solidFill>
           <a:ln>
             <a:noFill/>
@@ -4976,14 +5019,14 @@
       </p:sp>
       <p:sp>
         <p:nvSpPr>
-          <p:cNvPr id="44" name="TextBox 43"/>
+          <p:cNvPr id="45" name="TextBox 44"/>
           <p:cNvSpPr txBox="1"/>
           <p:nvPr/>
         </p:nvSpPr>
         <p:spPr>
           <a:xfrm>
-            <a:off x="8208264" y="4992624"/>
-            <a:ext cx="1642872" cy="201168"/>
+            <a:off x="8293608" y="4965192"/>
+            <a:ext cx="1645920" cy="201168"/>
           </a:xfrm>
           <a:prstGeom prst="rect">
             <a:avLst/>
@@ -4998,9 +5041,9 @@
           <a:p>
             <a:pPr algn="l"/>
             <a:r>
-              <a:rPr sz="900" b="0">
-                <a:solidFill>
-                  <a:srgbClr val="4A5B6A"/>
+              <a:rPr sz="1100" b="0">
+                <a:solidFill>
+                  <a:srgbClr val="6B6B6B"/>
                 </a:solidFill>
                 <a:latin typeface="Microsoft YaHei"/>
                 <a:ea typeface="Microsoft YaHei"/>
@@ -5012,14 +5055,14 @@
       </p:sp>
       <p:sp>
         <p:nvSpPr>
-          <p:cNvPr id="45" name="TextBox 44"/>
+          <p:cNvPr id="46" name="TextBox 45"/>
           <p:cNvSpPr txBox="1"/>
           <p:nvPr/>
         </p:nvSpPr>
         <p:spPr>
           <a:xfrm>
-            <a:off x="8208264" y="5193792"/>
-            <a:ext cx="1642872" cy="256032"/>
+            <a:off x="8293608" y="5166360"/>
+            <a:ext cx="1645920" cy="256032"/>
           </a:xfrm>
           <a:prstGeom prst="rect">
             <a:avLst/>
@@ -5034,9 +5077,9 @@
           <a:p>
             <a:pPr algn="l"/>
             <a:r>
-              <a:rPr sz="1100" b="1">
-                <a:solidFill>
-                  <a:srgbClr val="14283C"/>
+              <a:rPr sz="1100" b="0">
+                <a:solidFill>
+                  <a:srgbClr val="4A4A4A"/>
                 </a:solidFill>
                 <a:latin typeface="Microsoft YaHei"/>
                 <a:ea typeface="Microsoft YaHei"/>
@@ -5048,14 +5091,14 @@
       </p:sp>
       <p:sp>
         <p:nvSpPr>
-          <p:cNvPr id="46" name="TextBox 45"/>
+          <p:cNvPr id="47" name="TextBox 46"/>
           <p:cNvSpPr txBox="1"/>
           <p:nvPr/>
         </p:nvSpPr>
         <p:spPr>
           <a:xfrm>
-            <a:off x="8208264" y="5449824"/>
-            <a:ext cx="1642872" cy="256032"/>
+            <a:off x="8293608" y="5413248"/>
+            <a:ext cx="1645920" cy="292608"/>
           </a:xfrm>
           <a:prstGeom prst="rect">
             <a:avLst/>
@@ -5070,9 +5113,9 @@
           <a:p>
             <a:pPr algn="l"/>
             <a:r>
-              <a:rPr sz="1300" b="1">
-                <a:solidFill>
-                  <a:srgbClr val="C45C26"/>
+              <a:rPr sz="1800" b="1">
+                <a:solidFill>
+                  <a:srgbClr val="8B1A2B"/>
                 </a:solidFill>
                 <a:latin typeface="Microsoft YaHei"/>
                 <a:ea typeface="Microsoft YaHei"/>
@@ -5084,14 +5127,14 @@
       </p:sp>
       <p:sp>
         <p:nvSpPr>
-          <p:cNvPr id="47" name="Rectangle 46"/>
+          <p:cNvPr id="48" name="Rectangle 47"/>
           <p:cNvSpPr/>
           <p:nvPr/>
         </p:nvSpPr>
         <p:spPr>
           <a:xfrm>
-            <a:off x="9997440" y="4937760"/>
-            <a:ext cx="1844040" cy="868680"/>
+            <a:off x="10104120" y="4910328"/>
+            <a:ext cx="1847088" cy="868680"/>
           </a:xfrm>
           <a:prstGeom prst="rect">
             <a:avLst/>
@@ -5129,20 +5172,20 @@
       </p:sp>
       <p:sp>
         <p:nvSpPr>
-          <p:cNvPr id="48" name="Rectangle 47"/>
+          <p:cNvPr id="49" name="Rectangle 48"/>
           <p:cNvSpPr/>
           <p:nvPr/>
         </p:nvSpPr>
         <p:spPr>
           <a:xfrm>
-            <a:off x="9997440" y="4937760"/>
-            <a:ext cx="73152" cy="868680"/>
+            <a:off x="10104120" y="4910328"/>
+            <a:ext cx="50800" cy="868680"/>
           </a:xfrm>
           <a:prstGeom prst="rect">
             <a:avLst/>
           </a:prstGeom>
           <a:solidFill>
-            <a:srgbClr val="C45C26"/>
+            <a:srgbClr val="8B1A2B"/>
           </a:solidFill>
           <a:ln>
             <a:noFill/>
@@ -5172,14 +5215,14 @@
       </p:sp>
       <p:sp>
         <p:nvSpPr>
-          <p:cNvPr id="49" name="TextBox 48"/>
+          <p:cNvPr id="50" name="TextBox 49"/>
           <p:cNvSpPr txBox="1"/>
           <p:nvPr/>
         </p:nvSpPr>
         <p:spPr>
           <a:xfrm>
-            <a:off x="10143744" y="4992624"/>
-            <a:ext cx="1642872" cy="201168"/>
+            <a:off x="10250424" y="4965192"/>
+            <a:ext cx="1645920" cy="201168"/>
           </a:xfrm>
           <a:prstGeom prst="rect">
             <a:avLst/>
@@ -5194,9 +5237,9 @@
           <a:p>
             <a:pPr algn="l"/>
             <a:r>
-              <a:rPr sz="900" b="0">
-                <a:solidFill>
-                  <a:srgbClr val="4A5B6A"/>
+              <a:rPr sz="1100" b="0">
+                <a:solidFill>
+                  <a:srgbClr val="6B6B6B"/>
                 </a:solidFill>
                 <a:latin typeface="Microsoft YaHei"/>
                 <a:ea typeface="Microsoft YaHei"/>
@@ -5208,14 +5251,14 @@
       </p:sp>
       <p:sp>
         <p:nvSpPr>
-          <p:cNvPr id="50" name="TextBox 49"/>
+          <p:cNvPr id="51" name="TextBox 50"/>
           <p:cNvSpPr txBox="1"/>
           <p:nvPr/>
         </p:nvSpPr>
         <p:spPr>
           <a:xfrm>
-            <a:off x="10143744" y="5193792"/>
-            <a:ext cx="1642872" cy="256032"/>
+            <a:off x="10250424" y="5166360"/>
+            <a:ext cx="1645920" cy="256032"/>
           </a:xfrm>
           <a:prstGeom prst="rect">
             <a:avLst/>
@@ -5230,9 +5273,9 @@
           <a:p>
             <a:pPr algn="l"/>
             <a:r>
-              <a:rPr sz="1100" b="1">
-                <a:solidFill>
-                  <a:srgbClr val="14283C"/>
+              <a:rPr sz="1100" b="0">
+                <a:solidFill>
+                  <a:srgbClr val="4A4A4A"/>
                 </a:solidFill>
                 <a:latin typeface="Microsoft YaHei"/>
                 <a:ea typeface="Microsoft YaHei"/>
@@ -5244,14 +5287,14 @@
       </p:sp>
       <p:sp>
         <p:nvSpPr>
-          <p:cNvPr id="51" name="TextBox 50"/>
+          <p:cNvPr id="52" name="TextBox 51"/>
           <p:cNvSpPr txBox="1"/>
           <p:nvPr/>
         </p:nvSpPr>
         <p:spPr>
           <a:xfrm>
-            <a:off x="10143744" y="5449824"/>
-            <a:ext cx="1642872" cy="256032"/>
+            <a:off x="10250424" y="5413248"/>
+            <a:ext cx="1645920" cy="292608"/>
           </a:xfrm>
           <a:prstGeom prst="rect">
             <a:avLst/>
@@ -5266,9 +5309,9 @@
           <a:p>
             <a:pPr algn="l"/>
             <a:r>
-              <a:rPr sz="1300" b="1">
-                <a:solidFill>
-                  <a:srgbClr val="C45C26"/>
+              <a:rPr sz="1800" b="1">
+                <a:solidFill>
+                  <a:srgbClr val="8B1A2B"/>
                 </a:solidFill>
                 <a:latin typeface="Microsoft YaHei"/>
                 <a:ea typeface="Microsoft YaHei"/>
@@ -5280,20 +5323,20 @@
       </p:sp>
       <p:sp>
         <p:nvSpPr>
-          <p:cNvPr id="52" name="Rectangle 51"/>
+          <p:cNvPr id="53" name="Rectangle 52"/>
           <p:cNvSpPr/>
           <p:nvPr/>
         </p:nvSpPr>
         <p:spPr>
           <a:xfrm>
-            <a:off x="320040" y="5961888"/>
-            <a:ext cx="11521440" cy="685800"/>
+            <a:off x="0" y="5989320"/>
+            <a:ext cx="12191695" cy="868680"/>
           </a:xfrm>
           <a:prstGeom prst="rect">
             <a:avLst/>
           </a:prstGeom>
           <a:solidFill>
-            <a:srgbClr val="14283C"/>
+            <a:srgbClr val="FFFFFF"/>
           </a:solidFill>
           <a:ln>
             <a:noFill/>
@@ -5323,14 +5366,57 @@
       </p:sp>
       <p:sp>
         <p:nvSpPr>
-          <p:cNvPr id="53" name="TextBox 52"/>
+          <p:cNvPr id="54" name="Rectangle 53"/>
+          <p:cNvSpPr/>
+          <p:nvPr/>
+        </p:nvSpPr>
+        <p:spPr>
+          <a:xfrm>
+            <a:off x="0" y="5989320"/>
+            <a:ext cx="12191695" cy="25400"/>
+          </a:xfrm>
+          <a:prstGeom prst="rect">
+            <a:avLst/>
+          </a:prstGeom>
+          <a:solidFill>
+            <a:srgbClr val="8B1A2B"/>
+          </a:solidFill>
+          <a:ln>
+            <a:noFill/>
+          </a:ln>
+        </p:spPr>
+        <p:style>
+          <a:lnRef idx="1">
+            <a:schemeClr val="accent1"/>
+          </a:lnRef>
+          <a:fillRef idx="3">
+            <a:schemeClr val="accent1"/>
+          </a:fillRef>
+          <a:effectRef idx="2">
+            <a:schemeClr val="accent1"/>
+          </a:effectRef>
+          <a:fontRef idx="minor">
+            <a:schemeClr val="lt1"/>
+          </a:fontRef>
+        </p:style>
+        <p:txBody>
+          <a:bodyPr rtlCol="0" anchor="ctr"/>
+          <a:lstStyle/>
+          <a:p>
+            <a:pPr algn="ctr"/>
+          </a:p>
+        </p:txBody>
+      </p:sp>
+      <p:sp>
+        <p:nvSpPr>
+          <p:cNvPr id="55" name="TextBox 54"/>
           <p:cNvSpPr txBox="1"/>
           <p:nvPr/>
         </p:nvSpPr>
         <p:spPr>
           <a:xfrm>
-            <a:off x="457200" y="6035040"/>
-            <a:ext cx="11247120" cy="256032"/>
+            <a:off x="365760" y="6080760"/>
+            <a:ext cx="11430000" cy="256032"/>
           </a:xfrm>
           <a:prstGeom prst="rect">
             <a:avLst/>
@@ -5345,9 +5431,9 @@
           <a:p>
             <a:pPr algn="l"/>
             <a:r>
-              <a:rPr sz="1100" b="1">
-                <a:solidFill>
-                  <a:srgbClr val="FFFFFF"/>
+              <a:rPr sz="1200" b="1">
+                <a:solidFill>
+                  <a:srgbClr val="1A1A1A"/>
                 </a:solidFill>
                 <a:latin typeface="Microsoft YaHei"/>
                 <a:ea typeface="Microsoft YaHei"/>
@@ -5359,14 +5445,14 @@
       </p:sp>
       <p:sp>
         <p:nvSpPr>
-          <p:cNvPr id="54" name="TextBox 53"/>
+          <p:cNvPr id="56" name="TextBox 55"/>
           <p:cNvSpPr txBox="1"/>
           <p:nvPr/>
         </p:nvSpPr>
         <p:spPr>
           <a:xfrm>
-            <a:off x="457200" y="6327648"/>
-            <a:ext cx="11247120" cy="256032"/>
+            <a:off x="365760" y="6373368"/>
+            <a:ext cx="11430000" cy="256032"/>
           </a:xfrm>
           <a:prstGeom prst="rect">
             <a:avLst/>
@@ -5383,7 +5469,7 @@
             <a:r>
               <a:rPr sz="1000" b="0">
                 <a:solidFill>
-                  <a:srgbClr val="9BC9C6"/>
+                  <a:srgbClr val="6B6B6B"/>
                 </a:solidFill>
                 <a:latin typeface="Microsoft YaHei"/>
                 <a:ea typeface="Microsoft YaHei"/>

</xml_diff>

<commit_message>
Remove dark-red borders from one-page insight PPTs
Keep gray borders only; use dark red solely for title and metric text.

Co-authored-by: Annie <Annie-Summer@users.noreply.github.com>
</commit_message>
<xml_diff>
--- a/yunqi-2026-cipu-forum/docs/洞察一页-04-KVCache推理基础设施.pptx
+++ b/yunqi-2026-cipu-forum/docs/洞察一页-04-KVCache推理基础设施.pptx
@@ -3140,13 +3140,13 @@
         <p:spPr>
           <a:xfrm>
             <a:off x="0" y="0"/>
-            <a:ext cx="50800" cy="6858000"/>
+            <a:ext cx="12191695" cy="1051560"/>
           </a:xfrm>
           <a:prstGeom prst="rect">
             <a:avLst/>
           </a:prstGeom>
           <a:solidFill>
-            <a:srgbClr val="8B1A2B"/>
+            <a:srgbClr val="FFFFFF"/>
           </a:solidFill>
           <a:ln>
             <a:noFill/>
@@ -3176,14 +3176,86 @@
       </p:sp>
       <p:sp>
         <p:nvSpPr>
-          <p:cNvPr id="4" name="Rectangle 3"/>
+          <p:cNvPr id="4" name="TextBox 3"/>
+          <p:cNvSpPr txBox="1"/>
+          <p:nvPr/>
+        </p:nvSpPr>
+        <p:spPr>
+          <a:xfrm>
+            <a:off x="365760" y="146304"/>
+            <a:ext cx="11430000" cy="274320"/>
+          </a:xfrm>
+          <a:prstGeom prst="rect">
+            <a:avLst/>
+          </a:prstGeom>
+          <a:noFill/>
+        </p:spPr>
+        <p:txBody>
+          <a:bodyPr wrap="square">
+            <a:spAutoFit/>
+          </a:bodyPr>
+          <a:lstStyle/>
+          <a:p>
+            <a:pPr algn="l"/>
+            <a:r>
+              <a:rPr sz="1300" b="0">
+                <a:solidFill>
+                  <a:srgbClr val="6B6B6B"/>
+                </a:solidFill>
+                <a:latin typeface="Microsoft YaHei"/>
+                <a:ea typeface="Microsoft YaHei"/>
+              </a:rPr>
+              <a:t>04 · 王正恒 / 徐国强 · KVCache：从显存优化到软硬结合的推理基础设施</a:t>
+            </a:r>
+          </a:p>
+        </p:txBody>
+      </p:sp>
+      <p:sp>
+        <p:nvSpPr>
+          <p:cNvPr id="5" name="TextBox 4"/>
+          <p:cNvSpPr txBox="1"/>
+          <p:nvPr/>
+        </p:nvSpPr>
+        <p:spPr>
+          <a:xfrm>
+            <a:off x="365760" y="420624"/>
+            <a:ext cx="11430000" cy="502920"/>
+          </a:xfrm>
+          <a:prstGeom prst="rect">
+            <a:avLst/>
+          </a:prstGeom>
+          <a:noFill/>
+        </p:spPr>
+        <p:txBody>
+          <a:bodyPr wrap="square">
+            <a:spAutoFit/>
+          </a:bodyPr>
+          <a:lstStyle/>
+          <a:p>
+            <a:pPr algn="l"/>
+            <a:r>
+              <a:rPr sz="2200" b="1">
+                <a:solidFill>
+                  <a:srgbClr val="1A1A1A"/>
+                </a:solidFill>
+                <a:latin typeface="Microsoft YaHei"/>
+                <a:ea typeface="Microsoft YaHei"/>
+              </a:rPr>
+              <a:t>洞察：KVCache 已从框架技巧，升级为可调度的推理基础设施</a:t>
+            </a:r>
+          </a:p>
+        </p:txBody>
+      </p:sp>
+      <p:sp>
+        <p:nvSpPr>
+          <p:cNvPr id="6" name="Rectangle 5"/>
           <p:cNvSpPr/>
           <p:nvPr/>
         </p:nvSpPr>
         <p:spPr>
           <a:xfrm>
-            <a:off x="0" y="0"/>
-            <a:ext cx="12191695" cy="1051560"/>
+            <a:off x="320040" y="1207008"/>
+            <a:ext cx="11521440" cy="502920"/>
           </a:xfrm>
           <a:prstGeom prst="rect">
             <a:avLst/>
@@ -3191,8 +3263,10 @@
           <a:solidFill>
             <a:srgbClr val="FFFFFF"/>
           </a:solidFill>
-          <a:ln>
-            <a:noFill/>
+          <a:ln w="12700">
+            <a:solidFill>
+              <a:srgbClr val="D0D8DE"/>
+            </a:solidFill>
           </a:ln>
         </p:spPr>
         <p:style>
@@ -3219,23 +3293,61 @@
       </p:sp>
       <p:sp>
         <p:nvSpPr>
-          <p:cNvPr id="5" name="Rectangle 4"/>
+          <p:cNvPr id="7" name="TextBox 6"/>
+          <p:cNvSpPr txBox="1"/>
+          <p:nvPr/>
+        </p:nvSpPr>
+        <p:spPr>
+          <a:xfrm>
+            <a:off x="457200" y="1298448"/>
+            <a:ext cx="11247120" cy="365760"/>
+          </a:xfrm>
+          <a:prstGeom prst="rect">
+            <a:avLst/>
+          </a:prstGeom>
+          <a:noFill/>
+        </p:spPr>
+        <p:txBody>
+          <a:bodyPr wrap="square">
+            <a:spAutoFit/>
+          </a:bodyPr>
+          <a:lstStyle/>
+          <a:p>
+            <a:pPr algn="l"/>
+            <a:r>
+              <a:rPr sz="1400" b="1">
+                <a:solidFill>
+                  <a:srgbClr val="1A1A1A"/>
+                </a:solidFill>
+                <a:latin typeface="Microsoft YaHei"/>
+                <a:ea typeface="Microsoft YaHei"/>
+              </a:rPr>
+              <a:t>一句话判断：把 KV 当资产——控制面管放置/生命周期，数据面做分层池化；无仿真就没有可规模化的 SLO/TCO。</a:t>
+            </a:r>
+          </a:p>
+        </p:txBody>
+      </p:sp>
+      <p:sp>
+        <p:nvSpPr>
+          <p:cNvPr id="8" name="Rectangle 7"/>
           <p:cNvSpPr/>
           <p:nvPr/>
         </p:nvSpPr>
         <p:spPr>
           <a:xfrm>
-            <a:off x="0" y="1026160"/>
-            <a:ext cx="12191695" cy="25400"/>
+            <a:off x="320040" y="1874519"/>
+            <a:ext cx="3703320" cy="2606040"/>
           </a:xfrm>
           <a:prstGeom prst="rect">
             <a:avLst/>
           </a:prstGeom>
           <a:solidFill>
-            <a:srgbClr val="8B1A2B"/>
+            <a:srgbClr val="FFFFFF"/>
           </a:solidFill>
-          <a:ln>
-            <a:noFill/>
+          <a:ln w="12700">
+            <a:solidFill>
+              <a:srgbClr val="D0D8DE"/>
+            </a:solidFill>
           </a:ln>
         </p:spPr>
         <p:style>
@@ -3262,14 +3374,14 @@
       </p:sp>
       <p:sp>
         <p:nvSpPr>
-          <p:cNvPr id="6" name="TextBox 5"/>
+          <p:cNvPr id="9" name="TextBox 8"/>
           <p:cNvSpPr txBox="1"/>
           <p:nvPr/>
         </p:nvSpPr>
         <p:spPr>
           <a:xfrm>
-            <a:off x="365760" y="146304"/>
-            <a:ext cx="11430000" cy="274320"/>
+            <a:off x="457200" y="2011679"/>
+            <a:ext cx="3429000" cy="320040"/>
           </a:xfrm>
           <a:prstGeom prst="rect">
             <a:avLst/>
@@ -3284,28 +3396,28 @@
           <a:p>
             <a:pPr algn="l"/>
             <a:r>
-              <a:rPr sz="1300" b="0">
-                <a:solidFill>
-                  <a:srgbClr val="6B6B6B"/>
+              <a:rPr sz="1600" b="1">
+                <a:solidFill>
+                  <a:srgbClr val="8B1A2B"/>
                 </a:solidFill>
                 <a:latin typeface="Microsoft YaHei"/>
                 <a:ea typeface="Microsoft YaHei"/>
               </a:rPr>
-              <a:t>04 · 王正恒 / 徐国强 · KVCache：从显存优化到软硬结合的推理基础设施</a:t>
-            </a:r>
-          </a:p>
-        </p:txBody>
-      </p:sp>
-      <p:sp>
-        <p:nvSpPr>
-          <p:cNvPr id="7" name="TextBox 6"/>
+              <a:t>01  三跃迁：资产化</a:t>
+            </a:r>
+          </a:p>
+        </p:txBody>
+      </p:sp>
+      <p:sp>
+        <p:nvSpPr>
+          <p:cNvPr id="10" name="TextBox 9"/>
           <p:cNvSpPr txBox="1"/>
           <p:nvPr/>
         </p:nvSpPr>
         <p:spPr>
           <a:xfrm>
-            <a:off x="365760" y="420624"/>
-            <a:ext cx="11430000" cy="502920"/>
+            <a:off x="484632" y="2377439"/>
+            <a:ext cx="3374136" cy="1965960"/>
           </a:xfrm>
           <a:prstGeom prst="rect">
             <a:avLst/>
@@ -3318,30 +3430,102 @@
           </a:bodyPr>
           <a:lstStyle/>
           <a:p>
-            <a:pPr algn="l"/>
-            <a:r>
-              <a:rPr sz="2200" b="1">
+            <a:pPr algn="l">
+              <a:spcAft>
+                <a:spcPts val="500"/>
+              </a:spcAft>
+            </a:pPr>
+            <a:r>
+              <a:rPr sz="1300" b="1">
                 <a:solidFill>
                   <a:srgbClr val="1A1A1A"/>
                 </a:solidFill>
                 <a:latin typeface="Microsoft YaHei"/>
                 <a:ea typeface="Microsoft YaHei"/>
               </a:rPr>
-              <a:t>洞察：KVCache 已从框架技巧，升级为可调度的推理基础设施</a:t>
-            </a:r>
-          </a:p>
-        </p:txBody>
-      </p:sp>
-      <p:sp>
-        <p:nvSpPr>
-          <p:cNvPr id="8" name="Rectangle 7"/>
+              <a:t>从显存开销 → 可复用推理资产</a:t>
+            </a:r>
+          </a:p>
+          <a:p>
+            <a:pPr algn="l">
+              <a:spcAft>
+                <a:spcPts val="500"/>
+              </a:spcAft>
+            </a:pPr>
+            <a:r>
+              <a:rPr sz="1300" b="0">
+                <a:solidFill>
+                  <a:srgbClr val="4A4A4A"/>
+                </a:solidFill>
+                <a:latin typeface="Microsoft YaHei"/>
+                <a:ea typeface="Microsoft YaHei"/>
+              </a:rPr>
+              <a:t>• 前缀命中：跳过 Prefill，降 TTFT</a:t>
+            </a:r>
+          </a:p>
+          <a:p>
+            <a:pPr algn="l">
+              <a:spcAft>
+                <a:spcPts val="500"/>
+              </a:spcAft>
+            </a:pPr>
+            <a:r>
+              <a:rPr sz="1300" b="0">
+                <a:solidFill>
+                  <a:srgbClr val="4A4A4A"/>
+                </a:solidFill>
+                <a:latin typeface="Microsoft YaHei"/>
+                <a:ea typeface="Microsoft YaHei"/>
+              </a:rPr>
+              <a:t>• Agentic 多轮：KV 跨轮持久</a:t>
+            </a:r>
+          </a:p>
+          <a:p>
+            <a:pPr algn="l">
+              <a:spcAft>
+                <a:spcPts val="500"/>
+              </a:spcAft>
+            </a:pPr>
+            <a:r>
+              <a:rPr sz="1300" b="0">
+                <a:solidFill>
+                  <a:srgbClr val="4A4A4A"/>
+                </a:solidFill>
+                <a:latin typeface="Microsoft YaHei"/>
+                <a:ea typeface="Microsoft YaHei"/>
+              </a:rPr>
+              <a:t>• 跨实例池化：容量与计算解耦</a:t>
+            </a:r>
+          </a:p>
+          <a:p>
+            <a:pPr algn="l">
+              <a:spcAft>
+                <a:spcPts val="500"/>
+              </a:spcAft>
+            </a:pPr>
+            <a:r>
+              <a:rPr sz="1300" b="0">
+                <a:solidFill>
+                  <a:srgbClr val="4A4A4A"/>
+                </a:solidFill>
+                <a:latin typeface="Microsoft YaHei"/>
+                <a:ea typeface="Microsoft YaHei"/>
+              </a:rPr>
+              <a:t>• KV Aware Routing 感知放置</a:t>
+            </a:r>
+          </a:p>
+        </p:txBody>
+      </p:sp>
+      <p:sp>
+        <p:nvSpPr>
+          <p:cNvPr id="11" name="Rectangle 10"/>
           <p:cNvSpPr/>
           <p:nvPr/>
         </p:nvSpPr>
         <p:spPr>
           <a:xfrm>
-            <a:off x="320040" y="1207008"/>
-            <a:ext cx="11521440" cy="502920"/>
+            <a:off x="4224528" y="1874519"/>
+            <a:ext cx="3703320" cy="2606040"/>
           </a:xfrm>
           <a:prstGeom prst="rect">
             <a:avLst/>
@@ -3349,9 +3533,9 @@
           <a:solidFill>
             <a:srgbClr val="FFFFFF"/>
           </a:solidFill>
-          <a:ln w="19050">
+          <a:ln w="12700">
             <a:solidFill>
-              <a:srgbClr val="8B1A2B"/>
+              <a:srgbClr val="D0D8DE"/>
             </a:solidFill>
           </a:ln>
         </p:spPr>
@@ -3379,14 +3563,14 @@
       </p:sp>
       <p:sp>
         <p:nvSpPr>
-          <p:cNvPr id="9" name="TextBox 8"/>
+          <p:cNvPr id="12" name="TextBox 11"/>
           <p:cNvSpPr txBox="1"/>
           <p:nvPr/>
         </p:nvSpPr>
         <p:spPr>
           <a:xfrm>
-            <a:off x="457200" y="1298448"/>
-            <a:ext cx="11247120" cy="365760"/>
+            <a:off x="4361688" y="2011679"/>
+            <a:ext cx="3429000" cy="320040"/>
           </a:xfrm>
           <a:prstGeom prst="rect">
             <a:avLst/>
@@ -3401,27 +3585,135 @@
           <a:p>
             <a:pPr algn="l"/>
             <a:r>
-              <a:rPr sz="1400" b="1">
-                <a:solidFill>
-                  <a:srgbClr val="1A1A1A"/>
+              <a:rPr sz="1600" b="1">
+                <a:solidFill>
+                  <a:srgbClr val="8B1A2B"/>
                 </a:solidFill>
                 <a:latin typeface="Microsoft YaHei"/>
                 <a:ea typeface="Microsoft YaHei"/>
               </a:rPr>
-              <a:t>一句话判断：把 KV 当资产——控制面管放置/生命周期，数据面做分层池化；无仿真就没有可规模化的 SLO/TCO。</a:t>
-            </a:r>
-          </a:p>
-        </p:txBody>
-      </p:sp>
-      <p:sp>
-        <p:nvSpPr>
-          <p:cNvPr id="10" name="Rectangle 9"/>
+              <a:t>02  分层栈：破存储墙</a:t>
+            </a:r>
+          </a:p>
+        </p:txBody>
+      </p:sp>
+      <p:sp>
+        <p:nvSpPr>
+          <p:cNvPr id="13" name="TextBox 12"/>
+          <p:cNvSpPr txBox="1"/>
+          <p:nvPr/>
+        </p:nvSpPr>
+        <p:spPr>
+          <a:xfrm>
+            <a:off x="4389120" y="2377439"/>
+            <a:ext cx="3374136" cy="1965960"/>
+          </a:xfrm>
+          <a:prstGeom prst="rect">
+            <a:avLst/>
+          </a:prstGeom>
+          <a:noFill/>
+        </p:spPr>
+        <p:txBody>
+          <a:bodyPr wrap="square">
+            <a:spAutoFit/>
+          </a:bodyPr>
+          <a:lstStyle/>
+          <a:p>
+            <a:pPr algn="l">
+              <a:spcAft>
+                <a:spcPts val="500"/>
+              </a:spcAft>
+            </a:pPr>
+            <a:r>
+              <a:rPr sz="1300" b="1">
+                <a:solidFill>
+                  <a:srgbClr val="1A1A1A"/>
+                </a:solidFill>
+                <a:latin typeface="Microsoft YaHei"/>
+                <a:ea typeface="Microsoft YaHei"/>
+              </a:rPr>
+              <a:t>G1→G4 是标配，不是可选项</a:t>
+            </a:r>
+          </a:p>
+          <a:p>
+            <a:pPr algn="l">
+              <a:spcAft>
+                <a:spcPts val="500"/>
+              </a:spcAft>
+            </a:pPr>
+            <a:r>
+              <a:rPr sz="1300" b="0">
+                <a:solidFill>
+                  <a:srgbClr val="4A4A4A"/>
+                </a:solidFill>
+                <a:latin typeface="Microsoft YaHei"/>
+                <a:ea typeface="Microsoft YaHei"/>
+              </a:rPr>
+              <a:t>• G1 HBM / G1.5 UMX·AMES</a:t>
+            </a:r>
+          </a:p>
+          <a:p>
+            <a:pPr algn="l">
+              <a:spcAft>
+                <a:spcPts val="500"/>
+              </a:spcAft>
+            </a:pPr>
+            <a:r>
+              <a:rPr sz="1300" b="0">
+                <a:solidFill>
+                  <a:srgbClr val="4A4A4A"/>
+                </a:solidFill>
+                <a:latin typeface="Microsoft YaHei"/>
+                <a:ea typeface="Microsoft YaHei"/>
+              </a:rPr>
+              <a:t>• G2 DRAM / G2.5 CXL·RDMA 池</a:t>
+            </a:r>
+          </a:p>
+          <a:p>
+            <a:pPr algn="l">
+              <a:spcAft>
+                <a:spcPts val="500"/>
+              </a:spcAft>
+            </a:pPr>
+            <a:r>
+              <a:rPr sz="1300" b="0">
+                <a:solidFill>
+                  <a:srgbClr val="4A4A4A"/>
+                </a:solidFill>
+                <a:latin typeface="Microsoft YaHei"/>
+                <a:ea typeface="Microsoft YaHei"/>
+              </a:rPr>
+              <a:t>• G3 SSD / G3.5 EBoF / G4 对象</a:t>
+            </a:r>
+          </a:p>
+          <a:p>
+            <a:pPr algn="l">
+              <a:spcAft>
+                <a:spcPts val="500"/>
+              </a:spcAft>
+            </a:pPr>
+            <a:r>
+              <a:rPr sz="1300" b="0">
+                <a:solidFill>
+                  <a:srgbClr val="4A4A4A"/>
+                </a:solidFill>
+                <a:latin typeface="Microsoft YaHei"/>
+                <a:ea typeface="Microsoft YaHei"/>
+              </a:rPr>
+              <a:t>• UMX：UALink+CXL Load/Store</a:t>
+            </a:r>
+          </a:p>
+        </p:txBody>
+      </p:sp>
+      <p:sp>
+        <p:nvSpPr>
+          <p:cNvPr id="14" name="Rectangle 13"/>
           <p:cNvSpPr/>
           <p:nvPr/>
         </p:nvSpPr>
         <p:spPr>
           <a:xfrm>
-            <a:off x="320040" y="1874519"/>
+            <a:off x="8129016" y="1874519"/>
             <a:ext cx="3703320" cy="2606040"/>
           </a:xfrm>
           <a:prstGeom prst="rect">
@@ -3460,23 +3752,205 @@
       </p:sp>
       <p:sp>
         <p:nvSpPr>
-          <p:cNvPr id="11" name="Rectangle 10"/>
+          <p:cNvPr id="15" name="TextBox 14"/>
+          <p:cNvSpPr txBox="1"/>
+          <p:nvPr/>
+        </p:nvSpPr>
+        <p:spPr>
+          <a:xfrm>
+            <a:off x="8266176" y="2011679"/>
+            <a:ext cx="3429000" cy="320040"/>
+          </a:xfrm>
+          <a:prstGeom prst="rect">
+            <a:avLst/>
+          </a:prstGeom>
+          <a:noFill/>
+        </p:spPr>
+        <p:txBody>
+          <a:bodyPr wrap="square">
+            <a:spAutoFit/>
+          </a:bodyPr>
+          <a:lstStyle/>
+          <a:p>
+            <a:pPr algn="l"/>
+            <a:r>
+              <a:rPr sz="1600" b="1">
+                <a:solidFill>
+                  <a:srgbClr val="8B1A2B"/>
+                </a:solidFill>
+                <a:latin typeface="Microsoft YaHei"/>
+                <a:ea typeface="Microsoft YaHei"/>
+              </a:rPr>
+              <a:t>03  决策：仿真驱动</a:t>
+            </a:r>
+          </a:p>
+        </p:txBody>
+      </p:sp>
+      <p:sp>
+        <p:nvSpPr>
+          <p:cNvPr id="16" name="TextBox 15"/>
+          <p:cNvSpPr txBox="1"/>
+          <p:nvPr/>
+        </p:nvSpPr>
+        <p:spPr>
+          <a:xfrm>
+            <a:off x="8293608" y="2377439"/>
+            <a:ext cx="3374136" cy="1965960"/>
+          </a:xfrm>
+          <a:prstGeom prst="rect">
+            <a:avLst/>
+          </a:prstGeom>
+          <a:noFill/>
+        </p:spPr>
+        <p:txBody>
+          <a:bodyPr wrap="square">
+            <a:spAutoFit/>
+          </a:bodyPr>
+          <a:lstStyle/>
+          <a:p>
+            <a:pPr algn="l">
+              <a:spcAft>
+                <a:spcPts val="500"/>
+              </a:spcAft>
+            </a:pPr>
+            <a:r>
+              <a:rPr sz="1300" b="1">
+                <a:solidFill>
+                  <a:srgbClr val="1A1A1A"/>
+                </a:solidFill>
+                <a:latin typeface="Microsoft YaHei"/>
+                <a:ea typeface="Microsoft YaHei"/>
+              </a:rPr>
+              <a:t>经验调参 → HiSim Pareto/SLO</a:t>
+            </a:r>
+          </a:p>
+          <a:p>
+            <a:pPr algn="l">
+              <a:spcAft>
+                <a:spcPts val="500"/>
+              </a:spcAft>
+            </a:pPr>
+            <a:r>
+              <a:rPr sz="1300" b="0">
+                <a:solidFill>
+                  <a:srgbClr val="4A4A4A"/>
+                </a:solidFill>
+                <a:latin typeface="Microsoft YaHei"/>
+                <a:ea typeface="Microsoft YaHei"/>
+              </a:rPr>
+              <a:t>• KVCM 控制面 + MemPool 数据面</a:t>
+            </a:r>
+          </a:p>
+          <a:p>
+            <a:pPr algn="l">
+              <a:spcAft>
+                <a:spcPts val="500"/>
+              </a:spcAft>
+            </a:pPr>
+            <a:r>
+              <a:rPr sz="1300" b="0">
+                <a:solidFill>
+                  <a:srgbClr val="4A4A4A"/>
+                </a:solidFill>
+                <a:latin typeface="Microsoft YaHei"/>
+                <a:ea typeface="Microsoft YaHei"/>
+              </a:rPr>
+              <a:t>• 带宽/容量/寿命三约束取最大</a:t>
+            </a:r>
+          </a:p>
+          <a:p>
+            <a:pPr algn="l">
+              <a:spcAft>
+                <a:spcPts val="500"/>
+              </a:spcAft>
+            </a:pPr>
+            <a:r>
+              <a:rPr sz="1300" b="0">
+                <a:solidFill>
+                  <a:srgbClr val="4A4A4A"/>
+                </a:solidFill>
+                <a:latin typeface="Microsoft YaHei"/>
+                <a:ea typeface="Microsoft YaHei"/>
+              </a:rPr>
+              <a:t>• Token 级 TCO 进入平台指标</a:t>
+            </a:r>
+          </a:p>
+          <a:p>
+            <a:pPr algn="l">
+              <a:spcAft>
+                <a:spcPts val="500"/>
+              </a:spcAft>
+            </a:pPr>
+            <a:r>
+              <a:rPr sz="1300" b="0">
+                <a:solidFill>
+                  <a:srgbClr val="4A4A4A"/>
+                </a:solidFill>
+                <a:latin typeface="Microsoft YaHei"/>
+                <a:ea typeface="Microsoft YaHei"/>
+              </a:rPr>
+              <a:t>• 与 CIPU/引擎纵向对齐 L1–L4</a:t>
+            </a:r>
+          </a:p>
+        </p:txBody>
+      </p:sp>
+      <p:sp>
+        <p:nvSpPr>
+          <p:cNvPr id="17" name="TextBox 16"/>
+          <p:cNvSpPr txBox="1"/>
+          <p:nvPr/>
+        </p:nvSpPr>
+        <p:spPr>
+          <a:xfrm>
+            <a:off x="320040" y="4617720"/>
+            <a:ext cx="7315200" cy="256032"/>
+          </a:xfrm>
+          <a:prstGeom prst="rect">
+            <a:avLst/>
+          </a:prstGeom>
+          <a:noFill/>
+        </p:spPr>
+        <p:txBody>
+          <a:bodyPr wrap="square">
+            <a:spAutoFit/>
+          </a:bodyPr>
+          <a:lstStyle/>
+          <a:p>
+            <a:pPr algn="l"/>
+            <a:r>
+              <a:rPr sz="1400" b="1">
+                <a:solidFill>
+                  <a:srgbClr val="1A1A1A"/>
+                </a:solidFill>
+                <a:latin typeface="Microsoft YaHei"/>
+                <a:ea typeface="Microsoft YaHei"/>
+              </a:rPr>
+              <a:t>关键指标对比与提升</a:t>
+            </a:r>
+          </a:p>
+        </p:txBody>
+      </p:sp>
+      <p:sp>
+        <p:nvSpPr>
+          <p:cNvPr id="18" name="Rectangle 17"/>
           <p:cNvSpPr/>
           <p:nvPr/>
         </p:nvSpPr>
         <p:spPr>
           <a:xfrm>
-            <a:off x="320040" y="1874519"/>
-            <a:ext cx="3703320" cy="38100"/>
+            <a:off x="320040" y="4910328"/>
+            <a:ext cx="1847088" cy="868680"/>
           </a:xfrm>
           <a:prstGeom prst="rect">
             <a:avLst/>
           </a:prstGeom>
           <a:solidFill>
-            <a:srgbClr val="8B1A2B"/>
+            <a:srgbClr val="FFFFFF"/>
           </a:solidFill>
-          <a:ln>
-            <a:noFill/>
+          <a:ln w="12700">
+            <a:solidFill>
+              <a:srgbClr val="D0D8DE"/>
+            </a:solidFill>
           </a:ln>
         </p:spPr>
         <p:style>
@@ -3503,14 +3977,14 @@
       </p:sp>
       <p:sp>
         <p:nvSpPr>
-          <p:cNvPr id="12" name="TextBox 11"/>
+          <p:cNvPr id="19" name="TextBox 18"/>
           <p:cNvSpPr txBox="1"/>
           <p:nvPr/>
         </p:nvSpPr>
         <p:spPr>
           <a:xfrm>
-            <a:off x="457200" y="2011679"/>
-            <a:ext cx="3429000" cy="320040"/>
+            <a:off x="466344" y="4965192"/>
+            <a:ext cx="1645920" cy="201168"/>
           </a:xfrm>
           <a:prstGeom prst="rect">
             <a:avLst/>
@@ -3525,28 +3999,28 @@
           <a:p>
             <a:pPr algn="l"/>
             <a:r>
-              <a:rPr sz="1600" b="1">
-                <a:solidFill>
-                  <a:srgbClr val="8B1A2B"/>
+              <a:rPr sz="1100" b="0">
+                <a:solidFill>
+                  <a:srgbClr val="6B6B6B"/>
                 </a:solidFill>
                 <a:latin typeface="Microsoft YaHei"/>
                 <a:ea typeface="Microsoft YaHei"/>
               </a:rPr>
-              <a:t>01  三跃迁：资产化</a:t>
-            </a:r>
-          </a:p>
-        </p:txBody>
-      </p:sp>
-      <p:sp>
-        <p:nvSpPr>
-          <p:cNvPr id="13" name="TextBox 12"/>
+              <a:t>offload 吞吐</a:t>
+            </a:r>
+          </a:p>
+        </p:txBody>
+      </p:sp>
+      <p:sp>
+        <p:nvSpPr>
+          <p:cNvPr id="20" name="TextBox 19"/>
           <p:cNvSpPr txBox="1"/>
           <p:nvPr/>
         </p:nvSpPr>
         <p:spPr>
           <a:xfrm>
-            <a:off x="484632" y="2377439"/>
-            <a:ext cx="3374136" cy="1965960"/>
+            <a:off x="466344" y="5166360"/>
+            <a:ext cx="1645920" cy="256032"/>
           </a:xfrm>
           <a:prstGeom prst="rect">
             <a:avLst/>
@@ -3559,102 +4033,66 @@
           </a:bodyPr>
           <a:lstStyle/>
           <a:p>
-            <a:pPr algn="l">
-              <a:spcAft>
-                <a:spcPts val="500"/>
-              </a:spcAft>
-            </a:pPr>
-            <a:r>
-              <a:rPr sz="1300" b="1">
-                <a:solidFill>
-                  <a:srgbClr val="1A1A1A"/>
+            <a:pPr algn="l"/>
+            <a:r>
+              <a:rPr sz="1100" b="0">
+                <a:solidFill>
+                  <a:srgbClr val="4A4A4A"/>
                 </a:solidFill>
                 <a:latin typeface="Microsoft YaHei"/>
                 <a:ea typeface="Microsoft YaHei"/>
               </a:rPr>
-              <a:t>从显存开销 → 可复用推理资产</a:t>
-            </a:r>
-          </a:p>
-          <a:p>
-            <a:pPr algn="l">
-              <a:spcAft>
-                <a:spcPts val="500"/>
-              </a:spcAft>
-            </a:pPr>
-            <a:r>
-              <a:rPr sz="1300" b="0">
-                <a:solidFill>
-                  <a:srgbClr val="4A4A4A"/>
+              <a:t>未池化 → MemPool</a:t>
+            </a:r>
+          </a:p>
+        </p:txBody>
+      </p:sp>
+      <p:sp>
+        <p:nvSpPr>
+          <p:cNvPr id="21" name="TextBox 20"/>
+          <p:cNvSpPr txBox="1"/>
+          <p:nvPr/>
+        </p:nvSpPr>
+        <p:spPr>
+          <a:xfrm>
+            <a:off x="466344" y="5413248"/>
+            <a:ext cx="1645920" cy="292608"/>
+          </a:xfrm>
+          <a:prstGeom prst="rect">
+            <a:avLst/>
+          </a:prstGeom>
+          <a:noFill/>
+        </p:spPr>
+        <p:txBody>
+          <a:bodyPr wrap="square">
+            <a:spAutoFit/>
+          </a:bodyPr>
+          <a:lstStyle/>
+          <a:p>
+            <a:pPr algn="l"/>
+            <a:r>
+              <a:rPr sz="1800" b="1">
+                <a:solidFill>
+                  <a:srgbClr val="8B1A2B"/>
                 </a:solidFill>
                 <a:latin typeface="Microsoft YaHei"/>
                 <a:ea typeface="Microsoft YaHei"/>
               </a:rPr>
-              <a:t>• 前缀命中：跳过 Prefill，降 TTFT</a:t>
-            </a:r>
-          </a:p>
-          <a:p>
-            <a:pPr algn="l">
-              <a:spcAft>
-                <a:spcPts val="500"/>
-              </a:spcAft>
-            </a:pPr>
-            <a:r>
-              <a:rPr sz="1300" b="0">
-                <a:solidFill>
-                  <a:srgbClr val="4A4A4A"/>
-                </a:solidFill>
-                <a:latin typeface="Microsoft YaHei"/>
-                <a:ea typeface="Microsoft YaHei"/>
-              </a:rPr>
-              <a:t>• Agentic 多轮：KV 跨轮持久</a:t>
-            </a:r>
-          </a:p>
-          <a:p>
-            <a:pPr algn="l">
-              <a:spcAft>
-                <a:spcPts val="500"/>
-              </a:spcAft>
-            </a:pPr>
-            <a:r>
-              <a:rPr sz="1300" b="0">
-                <a:solidFill>
-                  <a:srgbClr val="4A4A4A"/>
-                </a:solidFill>
-                <a:latin typeface="Microsoft YaHei"/>
-                <a:ea typeface="Microsoft YaHei"/>
-              </a:rPr>
-              <a:t>• 跨实例池化：容量与计算解耦</a:t>
-            </a:r>
-          </a:p>
-          <a:p>
-            <a:pPr algn="l">
-              <a:spcAft>
-                <a:spcPts val="500"/>
-              </a:spcAft>
-            </a:pPr>
-            <a:r>
-              <a:rPr sz="1300" b="0">
-                <a:solidFill>
-                  <a:srgbClr val="4A4A4A"/>
-                </a:solidFill>
-                <a:latin typeface="Microsoft YaHei"/>
-                <a:ea typeface="Microsoft YaHei"/>
-              </a:rPr>
-              <a:t>• KV Aware Routing 感知放置</a:t>
-            </a:r>
-          </a:p>
-        </p:txBody>
-      </p:sp>
-      <p:sp>
-        <p:nvSpPr>
-          <p:cNvPr id="14" name="Rectangle 13"/>
+              <a:t>+50%+</a:t>
+            </a:r>
+          </a:p>
+        </p:txBody>
+      </p:sp>
+      <p:sp>
+        <p:nvSpPr>
+          <p:cNvPr id="22" name="Rectangle 21"/>
           <p:cNvSpPr/>
           <p:nvPr/>
         </p:nvSpPr>
         <p:spPr>
           <a:xfrm>
-            <a:off x="4224528" y="1874519"/>
-            <a:ext cx="3703320" cy="2606040"/>
+            <a:off x="2276856" y="4910328"/>
+            <a:ext cx="1847088" cy="868680"/>
           </a:xfrm>
           <a:prstGeom prst="rect">
             <a:avLst/>
@@ -3692,23 +4130,133 @@
       </p:sp>
       <p:sp>
         <p:nvSpPr>
-          <p:cNvPr id="15" name="Rectangle 14"/>
+          <p:cNvPr id="23" name="TextBox 22"/>
+          <p:cNvSpPr txBox="1"/>
+          <p:nvPr/>
+        </p:nvSpPr>
+        <p:spPr>
+          <a:xfrm>
+            <a:off x="2423160" y="4965192"/>
+            <a:ext cx="1645920" cy="201168"/>
+          </a:xfrm>
+          <a:prstGeom prst="rect">
+            <a:avLst/>
+          </a:prstGeom>
+          <a:noFill/>
+        </p:spPr>
+        <p:txBody>
+          <a:bodyPr wrap="square">
+            <a:spAutoFit/>
+          </a:bodyPr>
+          <a:lstStyle/>
+          <a:p>
+            <a:pPr algn="l"/>
+            <a:r>
+              <a:rPr sz="1100" b="0">
+                <a:solidFill>
+                  <a:srgbClr val="6B6B6B"/>
+                </a:solidFill>
+                <a:latin typeface="Microsoft YaHei"/>
+                <a:ea typeface="Microsoft YaHei"/>
+              </a:rPr>
+              <a:t>TTFT</a:t>
+            </a:r>
+          </a:p>
+        </p:txBody>
+      </p:sp>
+      <p:sp>
+        <p:nvSpPr>
+          <p:cNvPr id="24" name="TextBox 23"/>
+          <p:cNvSpPr txBox="1"/>
+          <p:nvPr/>
+        </p:nvSpPr>
+        <p:spPr>
+          <a:xfrm>
+            <a:off x="2423160" y="5166360"/>
+            <a:ext cx="1645920" cy="256032"/>
+          </a:xfrm>
+          <a:prstGeom prst="rect">
+            <a:avLst/>
+          </a:prstGeom>
+          <a:noFill/>
+        </p:spPr>
+        <p:txBody>
+          <a:bodyPr wrap="square">
+            <a:spAutoFit/>
+          </a:bodyPr>
+          <a:lstStyle/>
+          <a:p>
+            <a:pPr algn="l"/>
+            <a:r>
+              <a:rPr sz="1100" b="0">
+                <a:solidFill>
+                  <a:srgbClr val="4A4A4A"/>
+                </a:solidFill>
+                <a:latin typeface="Microsoft YaHei"/>
+                <a:ea typeface="Microsoft YaHei"/>
+              </a:rPr>
+              <a:t>未 offload → 池化</a:t>
+            </a:r>
+          </a:p>
+        </p:txBody>
+      </p:sp>
+      <p:sp>
+        <p:nvSpPr>
+          <p:cNvPr id="25" name="TextBox 24"/>
+          <p:cNvSpPr txBox="1"/>
+          <p:nvPr/>
+        </p:nvSpPr>
+        <p:spPr>
+          <a:xfrm>
+            <a:off x="2423160" y="5413248"/>
+            <a:ext cx="1645920" cy="292608"/>
+          </a:xfrm>
+          <a:prstGeom prst="rect">
+            <a:avLst/>
+          </a:prstGeom>
+          <a:noFill/>
+        </p:spPr>
+        <p:txBody>
+          <a:bodyPr wrap="square">
+            <a:spAutoFit/>
+          </a:bodyPr>
+          <a:lstStyle/>
+          <a:p>
+            <a:pPr algn="l"/>
+            <a:r>
+              <a:rPr sz="1800" b="1">
+                <a:solidFill>
+                  <a:srgbClr val="8B1A2B"/>
+                </a:solidFill>
+                <a:latin typeface="Microsoft YaHei"/>
+                <a:ea typeface="Microsoft YaHei"/>
+              </a:rPr>
+              <a:t>-30%</a:t>
+            </a:r>
+          </a:p>
+        </p:txBody>
+      </p:sp>
+      <p:sp>
+        <p:nvSpPr>
+          <p:cNvPr id="26" name="Rectangle 25"/>
           <p:cNvSpPr/>
           <p:nvPr/>
         </p:nvSpPr>
         <p:spPr>
           <a:xfrm>
-            <a:off x="4224528" y="1874519"/>
-            <a:ext cx="3703320" cy="38100"/>
+            <a:off x="4233672" y="4910328"/>
+            <a:ext cx="1847088" cy="868680"/>
           </a:xfrm>
           <a:prstGeom prst="rect">
             <a:avLst/>
           </a:prstGeom>
           <a:solidFill>
-            <a:srgbClr val="8B1A2B"/>
+            <a:srgbClr val="FFFFFF"/>
           </a:solidFill>
-          <a:ln>
-            <a:noFill/>
+          <a:ln w="12700">
+            <a:solidFill>
+              <a:srgbClr val="D0D8DE"/>
+            </a:solidFill>
           </a:ln>
         </p:spPr>
         <p:style>
@@ -3735,14 +4283,14 @@
       </p:sp>
       <p:sp>
         <p:nvSpPr>
-          <p:cNvPr id="16" name="TextBox 15"/>
+          <p:cNvPr id="27" name="TextBox 26"/>
           <p:cNvSpPr txBox="1"/>
           <p:nvPr/>
         </p:nvSpPr>
         <p:spPr>
           <a:xfrm>
-            <a:off x="4361688" y="2011679"/>
-            <a:ext cx="3429000" cy="320040"/>
+            <a:off x="4379976" y="4965192"/>
+            <a:ext cx="1645920" cy="201168"/>
           </a:xfrm>
           <a:prstGeom prst="rect">
             <a:avLst/>
@@ -3757,28 +4305,28 @@
           <a:p>
             <a:pPr algn="l"/>
             <a:r>
-              <a:rPr sz="1600" b="1">
-                <a:solidFill>
-                  <a:srgbClr val="8B1A2B"/>
+              <a:rPr sz="1100" b="0">
+                <a:solidFill>
+                  <a:srgbClr val="6B6B6B"/>
                 </a:solidFill>
                 <a:latin typeface="Microsoft YaHei"/>
                 <a:ea typeface="Microsoft YaHei"/>
               </a:rPr>
-              <a:t>02  分层栈：破存储墙</a:t>
-            </a:r>
-          </a:p>
-        </p:txBody>
-      </p:sp>
-      <p:sp>
-        <p:nvSpPr>
-          <p:cNvPr id="17" name="TextBox 16"/>
+              <a:t>传输效率</a:t>
+            </a:r>
+          </a:p>
+        </p:txBody>
+      </p:sp>
+      <p:sp>
+        <p:nvSpPr>
+          <p:cNvPr id="28" name="TextBox 27"/>
           <p:cNvSpPr txBox="1"/>
           <p:nvPr/>
         </p:nvSpPr>
         <p:spPr>
           <a:xfrm>
-            <a:off x="4389120" y="2377439"/>
-            <a:ext cx="3374136" cy="1965960"/>
+            <a:off x="4379976" y="5166360"/>
+            <a:ext cx="1645920" cy="256032"/>
           </a:xfrm>
           <a:prstGeom prst="rect">
             <a:avLst/>
@@ -3791,102 +4339,66 @@
           </a:bodyPr>
           <a:lstStyle/>
           <a:p>
-            <a:pPr algn="l">
-              <a:spcAft>
-                <a:spcPts val="500"/>
-              </a:spcAft>
-            </a:pPr>
-            <a:r>
-              <a:rPr sz="1300" b="1">
-                <a:solidFill>
-                  <a:srgbClr val="1A1A1A"/>
+            <a:pPr algn="l"/>
+            <a:r>
+              <a:rPr sz="1100" b="0">
+                <a:solidFill>
+                  <a:srgbClr val="4A4A4A"/>
                 </a:solidFill>
                 <a:latin typeface="Microsoft YaHei"/>
                 <a:ea typeface="Microsoft YaHei"/>
               </a:rPr>
-              <a:t>G1→G4 是标配，不是可选项</a:t>
-            </a:r>
-          </a:p>
-          <a:p>
-            <a:pPr algn="l">
-              <a:spcAft>
-                <a:spcPts val="500"/>
-              </a:spcAft>
-            </a:pPr>
-            <a:r>
-              <a:rPr sz="1300" b="0">
-                <a:solidFill>
-                  <a:srgbClr val="4A4A4A"/>
+              <a:t>多网卡数据面</a:t>
+            </a:r>
+          </a:p>
+        </p:txBody>
+      </p:sp>
+      <p:sp>
+        <p:nvSpPr>
+          <p:cNvPr id="29" name="TextBox 28"/>
+          <p:cNvSpPr txBox="1"/>
+          <p:nvPr/>
+        </p:nvSpPr>
+        <p:spPr>
+          <a:xfrm>
+            <a:off x="4379976" y="5413248"/>
+            <a:ext cx="1645920" cy="292608"/>
+          </a:xfrm>
+          <a:prstGeom prst="rect">
+            <a:avLst/>
+          </a:prstGeom>
+          <a:noFill/>
+        </p:spPr>
+        <p:txBody>
+          <a:bodyPr wrap="square">
+            <a:spAutoFit/>
+          </a:bodyPr>
+          <a:lstStyle/>
+          <a:p>
+            <a:pPr algn="l"/>
+            <a:r>
+              <a:rPr sz="1800" b="1">
+                <a:solidFill>
+                  <a:srgbClr val="8B1A2B"/>
                 </a:solidFill>
                 <a:latin typeface="Microsoft YaHei"/>
                 <a:ea typeface="Microsoft YaHei"/>
               </a:rPr>
-              <a:t>• G1 HBM / G1.5 UMX·AMES</a:t>
-            </a:r>
-          </a:p>
-          <a:p>
-            <a:pPr algn="l">
-              <a:spcAft>
-                <a:spcPts val="500"/>
-              </a:spcAft>
-            </a:pPr>
-            <a:r>
-              <a:rPr sz="1300" b="0">
-                <a:solidFill>
-                  <a:srgbClr val="4A4A4A"/>
-                </a:solidFill>
-                <a:latin typeface="Microsoft YaHei"/>
-                <a:ea typeface="Microsoft YaHei"/>
-              </a:rPr>
-              <a:t>• G2 DRAM / G2.5 CXL·RDMA 池</a:t>
-            </a:r>
-          </a:p>
-          <a:p>
-            <a:pPr algn="l">
-              <a:spcAft>
-                <a:spcPts val="500"/>
-              </a:spcAft>
-            </a:pPr>
-            <a:r>
-              <a:rPr sz="1300" b="0">
-                <a:solidFill>
-                  <a:srgbClr val="4A4A4A"/>
-                </a:solidFill>
-                <a:latin typeface="Microsoft YaHei"/>
-                <a:ea typeface="Microsoft YaHei"/>
-              </a:rPr>
-              <a:t>• G3 SSD / G3.5 EBoF / G4 对象</a:t>
-            </a:r>
-          </a:p>
-          <a:p>
-            <a:pPr algn="l">
-              <a:spcAft>
-                <a:spcPts val="500"/>
-              </a:spcAft>
-            </a:pPr>
-            <a:r>
-              <a:rPr sz="1300" b="0">
-                <a:solidFill>
-                  <a:srgbClr val="4A4A4A"/>
-                </a:solidFill>
-                <a:latin typeface="Microsoft YaHei"/>
-                <a:ea typeface="Microsoft YaHei"/>
-              </a:rPr>
-              <a:t>• UMX：UALink+CXL Load/Store</a:t>
-            </a:r>
-          </a:p>
-        </p:txBody>
-      </p:sp>
-      <p:sp>
-        <p:nvSpPr>
-          <p:cNvPr id="18" name="Rectangle 17"/>
+              <a:t>93%+</a:t>
+            </a:r>
+          </a:p>
+        </p:txBody>
+      </p:sp>
+      <p:sp>
+        <p:nvSpPr>
+          <p:cNvPr id="30" name="Rectangle 29"/>
           <p:cNvSpPr/>
           <p:nvPr/>
         </p:nvSpPr>
         <p:spPr>
           <a:xfrm>
-            <a:off x="8129016" y="1874519"/>
-            <a:ext cx="3703320" cy="2606040"/>
+            <a:off x="6190488" y="4910328"/>
+            <a:ext cx="1847088" cy="868680"/>
           </a:xfrm>
           <a:prstGeom prst="rect">
             <a:avLst/>
@@ -3924,23 +4436,133 @@
       </p:sp>
       <p:sp>
         <p:nvSpPr>
-          <p:cNvPr id="19" name="Rectangle 18"/>
+          <p:cNvPr id="31" name="TextBox 30"/>
+          <p:cNvSpPr txBox="1"/>
+          <p:nvPr/>
+        </p:nvSpPr>
+        <p:spPr>
+          <a:xfrm>
+            <a:off x="6336792" y="4965192"/>
+            <a:ext cx="1645920" cy="201168"/>
+          </a:xfrm>
+          <a:prstGeom prst="rect">
+            <a:avLst/>
+          </a:prstGeom>
+          <a:noFill/>
+        </p:spPr>
+        <p:txBody>
+          <a:bodyPr wrap="square">
+            <a:spAutoFit/>
+          </a:bodyPr>
+          <a:lstStyle/>
+          <a:p>
+            <a:pPr algn="l"/>
+            <a:r>
+              <a:rPr sz="1100" b="0">
+                <a:solidFill>
+                  <a:srgbClr val="6B6B6B"/>
+                </a:solidFill>
+                <a:latin typeface="Microsoft YaHei"/>
+                <a:ea typeface="Microsoft YaHei"/>
+              </a:rPr>
+              <a:t>Token TCO</a:t>
+            </a:r>
+          </a:p>
+        </p:txBody>
+      </p:sp>
+      <p:sp>
+        <p:nvSpPr>
+          <p:cNvPr id="32" name="TextBox 31"/>
+          <p:cNvSpPr txBox="1"/>
+          <p:nvPr/>
+        </p:nvSpPr>
+        <p:spPr>
+          <a:xfrm>
+            <a:off x="6336792" y="5166360"/>
+            <a:ext cx="1645920" cy="256032"/>
+          </a:xfrm>
+          <a:prstGeom prst="rect">
+            <a:avLst/>
+          </a:prstGeom>
+          <a:noFill/>
+        </p:spPr>
+        <p:txBody>
+          <a:bodyPr wrap="square">
+            <a:spAutoFit/>
+          </a:bodyPr>
+          <a:lstStyle/>
+          <a:p>
+            <a:pPr algn="l"/>
+            <a:r>
+              <a:rPr sz="1100" b="0">
+                <a:solidFill>
+                  <a:srgbClr val="4A4A4A"/>
+                </a:solidFill>
+                <a:latin typeface="Microsoft YaHei"/>
+                <a:ea typeface="Microsoft YaHei"/>
+              </a:rPr>
+              <a:t>DRAM 为主 → 分层</a:t>
+            </a:r>
+          </a:p>
+        </p:txBody>
+      </p:sp>
+      <p:sp>
+        <p:nvSpPr>
+          <p:cNvPr id="33" name="TextBox 32"/>
+          <p:cNvSpPr txBox="1"/>
+          <p:nvPr/>
+        </p:nvSpPr>
+        <p:spPr>
+          <a:xfrm>
+            <a:off x="6336792" y="5413248"/>
+            <a:ext cx="1645920" cy="292608"/>
+          </a:xfrm>
+          <a:prstGeom prst="rect">
+            <a:avLst/>
+          </a:prstGeom>
+          <a:noFill/>
+        </p:spPr>
+        <p:txBody>
+          <a:bodyPr wrap="square">
+            <a:spAutoFit/>
+          </a:bodyPr>
+          <a:lstStyle/>
+          <a:p>
+            <a:pPr algn="l"/>
+            <a:r>
+              <a:rPr sz="1800" b="1">
+                <a:solidFill>
+                  <a:srgbClr val="8B1A2B"/>
+                </a:solidFill>
+                <a:latin typeface="Microsoft YaHei"/>
+                <a:ea typeface="Microsoft YaHei"/>
+              </a:rPr>
+              <a:t>降幅&gt;80%*</a:t>
+            </a:r>
+          </a:p>
+        </p:txBody>
+      </p:sp>
+      <p:sp>
+        <p:nvSpPr>
+          <p:cNvPr id="34" name="Rectangle 33"/>
           <p:cNvSpPr/>
           <p:nvPr/>
         </p:nvSpPr>
         <p:spPr>
           <a:xfrm>
-            <a:off x="8129016" y="1874519"/>
-            <a:ext cx="3703320" cy="38100"/>
+            <a:off x="8147304" y="4910328"/>
+            <a:ext cx="1847088" cy="868680"/>
           </a:xfrm>
           <a:prstGeom prst="rect">
             <a:avLst/>
           </a:prstGeom>
           <a:solidFill>
-            <a:srgbClr val="8B1A2B"/>
+            <a:srgbClr val="FFFFFF"/>
           </a:solidFill>
-          <a:ln>
-            <a:noFill/>
+          <a:ln w="12700">
+            <a:solidFill>
+              <a:srgbClr val="D0D8DE"/>
+            </a:solidFill>
           </a:ln>
         </p:spPr>
         <p:style>
@@ -3967,14 +4589,14 @@
       </p:sp>
       <p:sp>
         <p:nvSpPr>
-          <p:cNvPr id="20" name="TextBox 19"/>
+          <p:cNvPr id="35" name="TextBox 34"/>
           <p:cNvSpPr txBox="1"/>
           <p:nvPr/>
         </p:nvSpPr>
         <p:spPr>
           <a:xfrm>
-            <a:off x="8266176" y="2011679"/>
-            <a:ext cx="3429000" cy="320040"/>
+            <a:off x="8293608" y="4965192"/>
+            <a:ext cx="1645920" cy="201168"/>
           </a:xfrm>
           <a:prstGeom prst="rect">
             <a:avLst/>
@@ -3989,28 +4611,28 @@
           <a:p>
             <a:pPr algn="l"/>
             <a:r>
-              <a:rPr sz="1600" b="1">
-                <a:solidFill>
-                  <a:srgbClr val="8B1A2B"/>
+              <a:rPr sz="1100" b="0">
+                <a:solidFill>
+                  <a:srgbClr val="6B6B6B"/>
                 </a:solidFill>
                 <a:latin typeface="Microsoft YaHei"/>
                 <a:ea typeface="Microsoft YaHei"/>
               </a:rPr>
-              <a:t>03  决策：仿真驱动</a:t>
-            </a:r>
-          </a:p>
-        </p:txBody>
-      </p:sp>
-      <p:sp>
-        <p:nvSpPr>
-          <p:cNvPr id="21" name="TextBox 20"/>
+              <a:t>HiSim 误差</a:t>
+            </a:r>
+          </a:p>
+        </p:txBody>
+      </p:sp>
+      <p:sp>
+        <p:nvSpPr>
+          <p:cNvPr id="36" name="TextBox 35"/>
           <p:cNvSpPr txBox="1"/>
           <p:nvPr/>
         </p:nvSpPr>
         <p:spPr>
           <a:xfrm>
-            <a:off x="8293608" y="2377439"/>
-            <a:ext cx="3374136" cy="1965960"/>
+            <a:off x="8293608" y="5166360"/>
+            <a:ext cx="1645920" cy="256032"/>
           </a:xfrm>
           <a:prstGeom prst="rect">
             <a:avLst/>
@@ -4023,102 +4645,30 @@
           </a:bodyPr>
           <a:lstStyle/>
           <a:p>
-            <a:pPr algn="l">
-              <a:spcAft>
-                <a:spcPts val="500"/>
-              </a:spcAft>
-            </a:pPr>
-            <a:r>
-              <a:rPr sz="1300" b="1">
-                <a:solidFill>
-                  <a:srgbClr val="1A1A1A"/>
+            <a:pPr algn="l"/>
+            <a:r>
+              <a:rPr sz="1100" b="0">
+                <a:solidFill>
+                  <a:srgbClr val="4A4A4A"/>
                 </a:solidFill>
                 <a:latin typeface="Microsoft YaHei"/>
                 <a:ea typeface="Microsoft YaHei"/>
               </a:rPr>
-              <a:t>经验调参 → HiSim Pareto/SLO</a:t>
-            </a:r>
-          </a:p>
-          <a:p>
-            <a:pPr algn="l">
-              <a:spcAft>
-                <a:spcPts val="500"/>
-              </a:spcAft>
-            </a:pPr>
-            <a:r>
-              <a:rPr sz="1300" b="0">
-                <a:solidFill>
-                  <a:srgbClr val="4A4A4A"/>
-                </a:solidFill>
-                <a:latin typeface="Microsoft YaHei"/>
-                <a:ea typeface="Microsoft YaHei"/>
-              </a:rPr>
-              <a:t>• KVCM 控制面 + MemPool 数据面</a:t>
-            </a:r>
-          </a:p>
-          <a:p>
-            <a:pPr algn="l">
-              <a:spcAft>
-                <a:spcPts val="500"/>
-              </a:spcAft>
-            </a:pPr>
-            <a:r>
-              <a:rPr sz="1300" b="0">
-                <a:solidFill>
-                  <a:srgbClr val="4A4A4A"/>
-                </a:solidFill>
-                <a:latin typeface="Microsoft YaHei"/>
-                <a:ea typeface="Microsoft YaHei"/>
-              </a:rPr>
-              <a:t>• 带宽/容量/寿命三约束取最大</a:t>
-            </a:r>
-          </a:p>
-          <a:p>
-            <a:pPr algn="l">
-              <a:spcAft>
-                <a:spcPts val="500"/>
-              </a:spcAft>
-            </a:pPr>
-            <a:r>
-              <a:rPr sz="1300" b="0">
-                <a:solidFill>
-                  <a:srgbClr val="4A4A4A"/>
-                </a:solidFill>
-                <a:latin typeface="Microsoft YaHei"/>
-                <a:ea typeface="Microsoft YaHei"/>
-              </a:rPr>
-              <a:t>• Token 级 TCO 进入平台指标</a:t>
-            </a:r>
-          </a:p>
-          <a:p>
-            <a:pPr algn="l">
-              <a:spcAft>
-                <a:spcPts val="500"/>
-              </a:spcAft>
-            </a:pPr>
-            <a:r>
-              <a:rPr sz="1300" b="0">
-                <a:solidFill>
-                  <a:srgbClr val="4A4A4A"/>
-                </a:solidFill>
-                <a:latin typeface="Microsoft YaHei"/>
-                <a:ea typeface="Microsoft YaHei"/>
-              </a:rPr>
-              <a:t>• 与 CIPU/引擎纵向对齐 L1–L4</a:t>
-            </a:r>
-          </a:p>
-        </p:txBody>
-      </p:sp>
-      <p:sp>
-        <p:nvSpPr>
-          <p:cNvPr id="22" name="TextBox 21"/>
+              <a:t>经验配置 → 仿真</a:t>
+            </a:r>
+          </a:p>
+        </p:txBody>
+      </p:sp>
+      <p:sp>
+        <p:nvSpPr>
+          <p:cNvPr id="37" name="TextBox 36"/>
           <p:cNvSpPr txBox="1"/>
           <p:nvPr/>
         </p:nvSpPr>
         <p:spPr>
           <a:xfrm>
-            <a:off x="320040" y="4617720"/>
-            <a:ext cx="7315200" cy="256032"/>
+            <a:off x="8293608" y="5413248"/>
+            <a:ext cx="1645920" cy="292608"/>
           </a:xfrm>
           <a:prstGeom prst="rect">
             <a:avLst/>
@@ -4133,27 +4683,27 @@
           <a:p>
             <a:pPr algn="l"/>
             <a:r>
-              <a:rPr sz="1400" b="1">
-                <a:solidFill>
-                  <a:srgbClr val="1A1A1A"/>
+              <a:rPr sz="1800" b="1">
+                <a:solidFill>
+                  <a:srgbClr val="8B1A2B"/>
                 </a:solidFill>
                 <a:latin typeface="Microsoft YaHei"/>
                 <a:ea typeface="Microsoft YaHei"/>
               </a:rPr>
-              <a:t>关键指标对比与提升</a:t>
-            </a:r>
-          </a:p>
-        </p:txBody>
-      </p:sp>
-      <p:sp>
-        <p:nvSpPr>
-          <p:cNvPr id="23" name="Rectangle 22"/>
+              <a:t>&lt;3%*</a:t>
+            </a:r>
+          </a:p>
+        </p:txBody>
+      </p:sp>
+      <p:sp>
+        <p:nvSpPr>
+          <p:cNvPr id="38" name="Rectangle 37"/>
           <p:cNvSpPr/>
           <p:nvPr/>
         </p:nvSpPr>
         <p:spPr>
           <a:xfrm>
-            <a:off x="320040" y="4910328"/>
+            <a:off x="10104120" y="4910328"/>
             <a:ext cx="1847088" cy="868680"/>
           </a:xfrm>
           <a:prstGeom prst="rect">
@@ -4192,20 +4742,128 @@
       </p:sp>
       <p:sp>
         <p:nvSpPr>
-          <p:cNvPr id="24" name="Rectangle 23"/>
+          <p:cNvPr id="39" name="TextBox 38"/>
+          <p:cNvSpPr txBox="1"/>
+          <p:nvPr/>
+        </p:nvSpPr>
+        <p:spPr>
+          <a:xfrm>
+            <a:off x="10250424" y="4965192"/>
+            <a:ext cx="1645920" cy="201168"/>
+          </a:xfrm>
+          <a:prstGeom prst="rect">
+            <a:avLst/>
+          </a:prstGeom>
+          <a:noFill/>
+        </p:spPr>
+        <p:txBody>
+          <a:bodyPr wrap="square">
+            <a:spAutoFit/>
+          </a:bodyPr>
+          <a:lstStyle/>
+          <a:p>
+            <a:pPr algn="l"/>
+            <a:r>
+              <a:rPr sz="1100" b="0">
+                <a:solidFill>
+                  <a:srgbClr val="6B6B6B"/>
+                </a:solidFill>
+                <a:latin typeface="Microsoft YaHei"/>
+                <a:ea typeface="Microsoft YaHei"/>
+              </a:rPr>
+              <a:t>分层形态</a:t>
+            </a:r>
+          </a:p>
+        </p:txBody>
+      </p:sp>
+      <p:sp>
+        <p:nvSpPr>
+          <p:cNvPr id="40" name="TextBox 39"/>
+          <p:cNvSpPr txBox="1"/>
+          <p:nvPr/>
+        </p:nvSpPr>
+        <p:spPr>
+          <a:xfrm>
+            <a:off x="10250424" y="5166360"/>
+            <a:ext cx="1645920" cy="256032"/>
+          </a:xfrm>
+          <a:prstGeom prst="rect">
+            <a:avLst/>
+          </a:prstGeom>
+          <a:noFill/>
+        </p:spPr>
+        <p:txBody>
+          <a:bodyPr wrap="square">
+            <a:spAutoFit/>
+          </a:bodyPr>
+          <a:lstStyle/>
+          <a:p>
+            <a:pPr algn="l"/>
+            <a:r>
+              <a:rPr sz="1100" b="0">
+                <a:solidFill>
+                  <a:srgbClr val="4A4A4A"/>
+                </a:solidFill>
+                <a:latin typeface="Microsoft YaHei"/>
+                <a:ea typeface="Microsoft YaHei"/>
+              </a:rPr>
+              <a:t>单机 HBM</a:t>
+            </a:r>
+          </a:p>
+        </p:txBody>
+      </p:sp>
+      <p:sp>
+        <p:nvSpPr>
+          <p:cNvPr id="41" name="TextBox 40"/>
+          <p:cNvSpPr txBox="1"/>
+          <p:nvPr/>
+        </p:nvSpPr>
+        <p:spPr>
+          <a:xfrm>
+            <a:off x="10250424" y="5413248"/>
+            <a:ext cx="1645920" cy="292608"/>
+          </a:xfrm>
+          <a:prstGeom prst="rect">
+            <a:avLst/>
+          </a:prstGeom>
+          <a:noFill/>
+        </p:spPr>
+        <p:txBody>
+          <a:bodyPr wrap="square">
+            <a:spAutoFit/>
+          </a:bodyPr>
+          <a:lstStyle/>
+          <a:p>
+            <a:pPr algn="l"/>
+            <a:r>
+              <a:rPr sz="1800" b="1">
+                <a:solidFill>
+                  <a:srgbClr val="8B1A2B"/>
+                </a:solidFill>
+                <a:latin typeface="Microsoft YaHei"/>
+                <a:ea typeface="Microsoft YaHei"/>
+              </a:rPr>
+              <a:t>G1–G4 栈</a:t>
+            </a:r>
+          </a:p>
+        </p:txBody>
+      </p:sp>
+      <p:sp>
+        <p:nvSpPr>
+          <p:cNvPr id="42" name="Rectangle 41"/>
           <p:cNvSpPr/>
           <p:nvPr/>
         </p:nvSpPr>
         <p:spPr>
           <a:xfrm>
-            <a:off x="320040" y="4910328"/>
-            <a:ext cx="50800" cy="868680"/>
+            <a:off x="0" y="5989320"/>
+            <a:ext cx="12191695" cy="868680"/>
           </a:xfrm>
           <a:prstGeom prst="rect">
             <a:avLst/>
           </a:prstGeom>
           <a:solidFill>
-            <a:srgbClr val="8B1A2B"/>
+            <a:srgbClr val="FFFFFF"/>
           </a:solidFill>
           <a:ln>
             <a:noFill/>
@@ -4235,14 +4893,14 @@
       </p:sp>
       <p:sp>
         <p:nvSpPr>
-          <p:cNvPr id="25" name="TextBox 24"/>
+          <p:cNvPr id="43" name="TextBox 42"/>
           <p:cNvSpPr txBox="1"/>
           <p:nvPr/>
         </p:nvSpPr>
         <p:spPr>
           <a:xfrm>
-            <a:off x="466344" y="4965192"/>
-            <a:ext cx="1645920" cy="201168"/>
+            <a:off x="365760" y="6080760"/>
+            <a:ext cx="11430000" cy="256032"/>
           </a:xfrm>
           <a:prstGeom prst="rect">
             <a:avLst/>
@@ -4257,1180 +4915,6 @@
           <a:p>
             <a:pPr algn="l"/>
             <a:r>
-              <a:rPr sz="1100" b="0">
-                <a:solidFill>
-                  <a:srgbClr val="6B6B6B"/>
-                </a:solidFill>
-                <a:latin typeface="Microsoft YaHei"/>
-                <a:ea typeface="Microsoft YaHei"/>
-              </a:rPr>
-              <a:t>offload 吞吐</a:t>
-            </a:r>
-          </a:p>
-        </p:txBody>
-      </p:sp>
-      <p:sp>
-        <p:nvSpPr>
-          <p:cNvPr id="26" name="TextBox 25"/>
-          <p:cNvSpPr txBox="1"/>
-          <p:nvPr/>
-        </p:nvSpPr>
-        <p:spPr>
-          <a:xfrm>
-            <a:off x="466344" y="5166360"/>
-            <a:ext cx="1645920" cy="256032"/>
-          </a:xfrm>
-          <a:prstGeom prst="rect">
-            <a:avLst/>
-          </a:prstGeom>
-          <a:noFill/>
-        </p:spPr>
-        <p:txBody>
-          <a:bodyPr wrap="square">
-            <a:spAutoFit/>
-          </a:bodyPr>
-          <a:lstStyle/>
-          <a:p>
-            <a:pPr algn="l"/>
-            <a:r>
-              <a:rPr sz="1100" b="0">
-                <a:solidFill>
-                  <a:srgbClr val="4A4A4A"/>
-                </a:solidFill>
-                <a:latin typeface="Microsoft YaHei"/>
-                <a:ea typeface="Microsoft YaHei"/>
-              </a:rPr>
-              <a:t>未池化 → MemPool</a:t>
-            </a:r>
-          </a:p>
-        </p:txBody>
-      </p:sp>
-      <p:sp>
-        <p:nvSpPr>
-          <p:cNvPr id="27" name="TextBox 26"/>
-          <p:cNvSpPr txBox="1"/>
-          <p:nvPr/>
-        </p:nvSpPr>
-        <p:spPr>
-          <a:xfrm>
-            <a:off x="466344" y="5413248"/>
-            <a:ext cx="1645920" cy="292608"/>
-          </a:xfrm>
-          <a:prstGeom prst="rect">
-            <a:avLst/>
-          </a:prstGeom>
-          <a:noFill/>
-        </p:spPr>
-        <p:txBody>
-          <a:bodyPr wrap="square">
-            <a:spAutoFit/>
-          </a:bodyPr>
-          <a:lstStyle/>
-          <a:p>
-            <a:pPr algn="l"/>
-            <a:r>
-              <a:rPr sz="1800" b="1">
-                <a:solidFill>
-                  <a:srgbClr val="8B1A2B"/>
-                </a:solidFill>
-                <a:latin typeface="Microsoft YaHei"/>
-                <a:ea typeface="Microsoft YaHei"/>
-              </a:rPr>
-              <a:t>+50%+</a:t>
-            </a:r>
-          </a:p>
-        </p:txBody>
-      </p:sp>
-      <p:sp>
-        <p:nvSpPr>
-          <p:cNvPr id="28" name="Rectangle 27"/>
-          <p:cNvSpPr/>
-          <p:nvPr/>
-        </p:nvSpPr>
-        <p:spPr>
-          <a:xfrm>
-            <a:off x="2276856" y="4910328"/>
-            <a:ext cx="1847088" cy="868680"/>
-          </a:xfrm>
-          <a:prstGeom prst="rect">
-            <a:avLst/>
-          </a:prstGeom>
-          <a:solidFill>
-            <a:srgbClr val="FFFFFF"/>
-          </a:solidFill>
-          <a:ln w="12700">
-            <a:solidFill>
-              <a:srgbClr val="D0D8DE"/>
-            </a:solidFill>
-          </a:ln>
-        </p:spPr>
-        <p:style>
-          <a:lnRef idx="1">
-            <a:schemeClr val="accent1"/>
-          </a:lnRef>
-          <a:fillRef idx="3">
-            <a:schemeClr val="accent1"/>
-          </a:fillRef>
-          <a:effectRef idx="2">
-            <a:schemeClr val="accent1"/>
-          </a:effectRef>
-          <a:fontRef idx="minor">
-            <a:schemeClr val="lt1"/>
-          </a:fontRef>
-        </p:style>
-        <p:txBody>
-          <a:bodyPr rtlCol="0" anchor="ctr"/>
-          <a:lstStyle/>
-          <a:p>
-            <a:pPr algn="ctr"/>
-          </a:p>
-        </p:txBody>
-      </p:sp>
-      <p:sp>
-        <p:nvSpPr>
-          <p:cNvPr id="29" name="Rectangle 28"/>
-          <p:cNvSpPr/>
-          <p:nvPr/>
-        </p:nvSpPr>
-        <p:spPr>
-          <a:xfrm>
-            <a:off x="2276856" y="4910328"/>
-            <a:ext cx="50800" cy="868680"/>
-          </a:xfrm>
-          <a:prstGeom prst="rect">
-            <a:avLst/>
-          </a:prstGeom>
-          <a:solidFill>
-            <a:srgbClr val="8B1A2B"/>
-          </a:solidFill>
-          <a:ln>
-            <a:noFill/>
-          </a:ln>
-        </p:spPr>
-        <p:style>
-          <a:lnRef idx="1">
-            <a:schemeClr val="accent1"/>
-          </a:lnRef>
-          <a:fillRef idx="3">
-            <a:schemeClr val="accent1"/>
-          </a:fillRef>
-          <a:effectRef idx="2">
-            <a:schemeClr val="accent1"/>
-          </a:effectRef>
-          <a:fontRef idx="minor">
-            <a:schemeClr val="lt1"/>
-          </a:fontRef>
-        </p:style>
-        <p:txBody>
-          <a:bodyPr rtlCol="0" anchor="ctr"/>
-          <a:lstStyle/>
-          <a:p>
-            <a:pPr algn="ctr"/>
-          </a:p>
-        </p:txBody>
-      </p:sp>
-      <p:sp>
-        <p:nvSpPr>
-          <p:cNvPr id="30" name="TextBox 29"/>
-          <p:cNvSpPr txBox="1"/>
-          <p:nvPr/>
-        </p:nvSpPr>
-        <p:spPr>
-          <a:xfrm>
-            <a:off x="2423160" y="4965192"/>
-            <a:ext cx="1645920" cy="201168"/>
-          </a:xfrm>
-          <a:prstGeom prst="rect">
-            <a:avLst/>
-          </a:prstGeom>
-          <a:noFill/>
-        </p:spPr>
-        <p:txBody>
-          <a:bodyPr wrap="square">
-            <a:spAutoFit/>
-          </a:bodyPr>
-          <a:lstStyle/>
-          <a:p>
-            <a:pPr algn="l"/>
-            <a:r>
-              <a:rPr sz="1100" b="0">
-                <a:solidFill>
-                  <a:srgbClr val="6B6B6B"/>
-                </a:solidFill>
-                <a:latin typeface="Microsoft YaHei"/>
-                <a:ea typeface="Microsoft YaHei"/>
-              </a:rPr>
-              <a:t>TTFT</a:t>
-            </a:r>
-          </a:p>
-        </p:txBody>
-      </p:sp>
-      <p:sp>
-        <p:nvSpPr>
-          <p:cNvPr id="31" name="TextBox 30"/>
-          <p:cNvSpPr txBox="1"/>
-          <p:nvPr/>
-        </p:nvSpPr>
-        <p:spPr>
-          <a:xfrm>
-            <a:off x="2423160" y="5166360"/>
-            <a:ext cx="1645920" cy="256032"/>
-          </a:xfrm>
-          <a:prstGeom prst="rect">
-            <a:avLst/>
-          </a:prstGeom>
-          <a:noFill/>
-        </p:spPr>
-        <p:txBody>
-          <a:bodyPr wrap="square">
-            <a:spAutoFit/>
-          </a:bodyPr>
-          <a:lstStyle/>
-          <a:p>
-            <a:pPr algn="l"/>
-            <a:r>
-              <a:rPr sz="1100" b="0">
-                <a:solidFill>
-                  <a:srgbClr val="4A4A4A"/>
-                </a:solidFill>
-                <a:latin typeface="Microsoft YaHei"/>
-                <a:ea typeface="Microsoft YaHei"/>
-              </a:rPr>
-              <a:t>未 offload → 池化</a:t>
-            </a:r>
-          </a:p>
-        </p:txBody>
-      </p:sp>
-      <p:sp>
-        <p:nvSpPr>
-          <p:cNvPr id="32" name="TextBox 31"/>
-          <p:cNvSpPr txBox="1"/>
-          <p:nvPr/>
-        </p:nvSpPr>
-        <p:spPr>
-          <a:xfrm>
-            <a:off x="2423160" y="5413248"/>
-            <a:ext cx="1645920" cy="292608"/>
-          </a:xfrm>
-          <a:prstGeom prst="rect">
-            <a:avLst/>
-          </a:prstGeom>
-          <a:noFill/>
-        </p:spPr>
-        <p:txBody>
-          <a:bodyPr wrap="square">
-            <a:spAutoFit/>
-          </a:bodyPr>
-          <a:lstStyle/>
-          <a:p>
-            <a:pPr algn="l"/>
-            <a:r>
-              <a:rPr sz="1800" b="1">
-                <a:solidFill>
-                  <a:srgbClr val="8B1A2B"/>
-                </a:solidFill>
-                <a:latin typeface="Microsoft YaHei"/>
-                <a:ea typeface="Microsoft YaHei"/>
-              </a:rPr>
-              <a:t>-30%</a:t>
-            </a:r>
-          </a:p>
-        </p:txBody>
-      </p:sp>
-      <p:sp>
-        <p:nvSpPr>
-          <p:cNvPr id="33" name="Rectangle 32"/>
-          <p:cNvSpPr/>
-          <p:nvPr/>
-        </p:nvSpPr>
-        <p:spPr>
-          <a:xfrm>
-            <a:off x="4233672" y="4910328"/>
-            <a:ext cx="1847088" cy="868680"/>
-          </a:xfrm>
-          <a:prstGeom prst="rect">
-            <a:avLst/>
-          </a:prstGeom>
-          <a:solidFill>
-            <a:srgbClr val="FFFFFF"/>
-          </a:solidFill>
-          <a:ln w="12700">
-            <a:solidFill>
-              <a:srgbClr val="D0D8DE"/>
-            </a:solidFill>
-          </a:ln>
-        </p:spPr>
-        <p:style>
-          <a:lnRef idx="1">
-            <a:schemeClr val="accent1"/>
-          </a:lnRef>
-          <a:fillRef idx="3">
-            <a:schemeClr val="accent1"/>
-          </a:fillRef>
-          <a:effectRef idx="2">
-            <a:schemeClr val="accent1"/>
-          </a:effectRef>
-          <a:fontRef idx="minor">
-            <a:schemeClr val="lt1"/>
-          </a:fontRef>
-        </p:style>
-        <p:txBody>
-          <a:bodyPr rtlCol="0" anchor="ctr"/>
-          <a:lstStyle/>
-          <a:p>
-            <a:pPr algn="ctr"/>
-          </a:p>
-        </p:txBody>
-      </p:sp>
-      <p:sp>
-        <p:nvSpPr>
-          <p:cNvPr id="34" name="Rectangle 33"/>
-          <p:cNvSpPr/>
-          <p:nvPr/>
-        </p:nvSpPr>
-        <p:spPr>
-          <a:xfrm>
-            <a:off x="4233672" y="4910328"/>
-            <a:ext cx="50800" cy="868680"/>
-          </a:xfrm>
-          <a:prstGeom prst="rect">
-            <a:avLst/>
-          </a:prstGeom>
-          <a:solidFill>
-            <a:srgbClr val="8B1A2B"/>
-          </a:solidFill>
-          <a:ln>
-            <a:noFill/>
-          </a:ln>
-        </p:spPr>
-        <p:style>
-          <a:lnRef idx="1">
-            <a:schemeClr val="accent1"/>
-          </a:lnRef>
-          <a:fillRef idx="3">
-            <a:schemeClr val="accent1"/>
-          </a:fillRef>
-          <a:effectRef idx="2">
-            <a:schemeClr val="accent1"/>
-          </a:effectRef>
-          <a:fontRef idx="minor">
-            <a:schemeClr val="lt1"/>
-          </a:fontRef>
-        </p:style>
-        <p:txBody>
-          <a:bodyPr rtlCol="0" anchor="ctr"/>
-          <a:lstStyle/>
-          <a:p>
-            <a:pPr algn="ctr"/>
-          </a:p>
-        </p:txBody>
-      </p:sp>
-      <p:sp>
-        <p:nvSpPr>
-          <p:cNvPr id="35" name="TextBox 34"/>
-          <p:cNvSpPr txBox="1"/>
-          <p:nvPr/>
-        </p:nvSpPr>
-        <p:spPr>
-          <a:xfrm>
-            <a:off x="4379976" y="4965192"/>
-            <a:ext cx="1645920" cy="201168"/>
-          </a:xfrm>
-          <a:prstGeom prst="rect">
-            <a:avLst/>
-          </a:prstGeom>
-          <a:noFill/>
-        </p:spPr>
-        <p:txBody>
-          <a:bodyPr wrap="square">
-            <a:spAutoFit/>
-          </a:bodyPr>
-          <a:lstStyle/>
-          <a:p>
-            <a:pPr algn="l"/>
-            <a:r>
-              <a:rPr sz="1100" b="0">
-                <a:solidFill>
-                  <a:srgbClr val="6B6B6B"/>
-                </a:solidFill>
-                <a:latin typeface="Microsoft YaHei"/>
-                <a:ea typeface="Microsoft YaHei"/>
-              </a:rPr>
-              <a:t>传输效率</a:t>
-            </a:r>
-          </a:p>
-        </p:txBody>
-      </p:sp>
-      <p:sp>
-        <p:nvSpPr>
-          <p:cNvPr id="36" name="TextBox 35"/>
-          <p:cNvSpPr txBox="1"/>
-          <p:nvPr/>
-        </p:nvSpPr>
-        <p:spPr>
-          <a:xfrm>
-            <a:off x="4379976" y="5166360"/>
-            <a:ext cx="1645920" cy="256032"/>
-          </a:xfrm>
-          <a:prstGeom prst="rect">
-            <a:avLst/>
-          </a:prstGeom>
-          <a:noFill/>
-        </p:spPr>
-        <p:txBody>
-          <a:bodyPr wrap="square">
-            <a:spAutoFit/>
-          </a:bodyPr>
-          <a:lstStyle/>
-          <a:p>
-            <a:pPr algn="l"/>
-            <a:r>
-              <a:rPr sz="1100" b="0">
-                <a:solidFill>
-                  <a:srgbClr val="4A4A4A"/>
-                </a:solidFill>
-                <a:latin typeface="Microsoft YaHei"/>
-                <a:ea typeface="Microsoft YaHei"/>
-              </a:rPr>
-              <a:t>多网卡数据面</a:t>
-            </a:r>
-          </a:p>
-        </p:txBody>
-      </p:sp>
-      <p:sp>
-        <p:nvSpPr>
-          <p:cNvPr id="37" name="TextBox 36"/>
-          <p:cNvSpPr txBox="1"/>
-          <p:nvPr/>
-        </p:nvSpPr>
-        <p:spPr>
-          <a:xfrm>
-            <a:off x="4379976" y="5413248"/>
-            <a:ext cx="1645920" cy="292608"/>
-          </a:xfrm>
-          <a:prstGeom prst="rect">
-            <a:avLst/>
-          </a:prstGeom>
-          <a:noFill/>
-        </p:spPr>
-        <p:txBody>
-          <a:bodyPr wrap="square">
-            <a:spAutoFit/>
-          </a:bodyPr>
-          <a:lstStyle/>
-          <a:p>
-            <a:pPr algn="l"/>
-            <a:r>
-              <a:rPr sz="1800" b="1">
-                <a:solidFill>
-                  <a:srgbClr val="8B1A2B"/>
-                </a:solidFill>
-                <a:latin typeface="Microsoft YaHei"/>
-                <a:ea typeface="Microsoft YaHei"/>
-              </a:rPr>
-              <a:t>93%+</a:t>
-            </a:r>
-          </a:p>
-        </p:txBody>
-      </p:sp>
-      <p:sp>
-        <p:nvSpPr>
-          <p:cNvPr id="38" name="Rectangle 37"/>
-          <p:cNvSpPr/>
-          <p:nvPr/>
-        </p:nvSpPr>
-        <p:spPr>
-          <a:xfrm>
-            <a:off x="6190488" y="4910328"/>
-            <a:ext cx="1847088" cy="868680"/>
-          </a:xfrm>
-          <a:prstGeom prst="rect">
-            <a:avLst/>
-          </a:prstGeom>
-          <a:solidFill>
-            <a:srgbClr val="FFFFFF"/>
-          </a:solidFill>
-          <a:ln w="12700">
-            <a:solidFill>
-              <a:srgbClr val="D0D8DE"/>
-            </a:solidFill>
-          </a:ln>
-        </p:spPr>
-        <p:style>
-          <a:lnRef idx="1">
-            <a:schemeClr val="accent1"/>
-          </a:lnRef>
-          <a:fillRef idx="3">
-            <a:schemeClr val="accent1"/>
-          </a:fillRef>
-          <a:effectRef idx="2">
-            <a:schemeClr val="accent1"/>
-          </a:effectRef>
-          <a:fontRef idx="minor">
-            <a:schemeClr val="lt1"/>
-          </a:fontRef>
-        </p:style>
-        <p:txBody>
-          <a:bodyPr rtlCol="0" anchor="ctr"/>
-          <a:lstStyle/>
-          <a:p>
-            <a:pPr algn="ctr"/>
-          </a:p>
-        </p:txBody>
-      </p:sp>
-      <p:sp>
-        <p:nvSpPr>
-          <p:cNvPr id="39" name="Rectangle 38"/>
-          <p:cNvSpPr/>
-          <p:nvPr/>
-        </p:nvSpPr>
-        <p:spPr>
-          <a:xfrm>
-            <a:off x="6190488" y="4910328"/>
-            <a:ext cx="50800" cy="868680"/>
-          </a:xfrm>
-          <a:prstGeom prst="rect">
-            <a:avLst/>
-          </a:prstGeom>
-          <a:solidFill>
-            <a:srgbClr val="8B1A2B"/>
-          </a:solidFill>
-          <a:ln>
-            <a:noFill/>
-          </a:ln>
-        </p:spPr>
-        <p:style>
-          <a:lnRef idx="1">
-            <a:schemeClr val="accent1"/>
-          </a:lnRef>
-          <a:fillRef idx="3">
-            <a:schemeClr val="accent1"/>
-          </a:fillRef>
-          <a:effectRef idx="2">
-            <a:schemeClr val="accent1"/>
-          </a:effectRef>
-          <a:fontRef idx="minor">
-            <a:schemeClr val="lt1"/>
-          </a:fontRef>
-        </p:style>
-        <p:txBody>
-          <a:bodyPr rtlCol="0" anchor="ctr"/>
-          <a:lstStyle/>
-          <a:p>
-            <a:pPr algn="ctr"/>
-          </a:p>
-        </p:txBody>
-      </p:sp>
-      <p:sp>
-        <p:nvSpPr>
-          <p:cNvPr id="40" name="TextBox 39"/>
-          <p:cNvSpPr txBox="1"/>
-          <p:nvPr/>
-        </p:nvSpPr>
-        <p:spPr>
-          <a:xfrm>
-            <a:off x="6336792" y="4965192"/>
-            <a:ext cx="1645920" cy="201168"/>
-          </a:xfrm>
-          <a:prstGeom prst="rect">
-            <a:avLst/>
-          </a:prstGeom>
-          <a:noFill/>
-        </p:spPr>
-        <p:txBody>
-          <a:bodyPr wrap="square">
-            <a:spAutoFit/>
-          </a:bodyPr>
-          <a:lstStyle/>
-          <a:p>
-            <a:pPr algn="l"/>
-            <a:r>
-              <a:rPr sz="1100" b="0">
-                <a:solidFill>
-                  <a:srgbClr val="6B6B6B"/>
-                </a:solidFill>
-                <a:latin typeface="Microsoft YaHei"/>
-                <a:ea typeface="Microsoft YaHei"/>
-              </a:rPr>
-              <a:t>Token TCO</a:t>
-            </a:r>
-          </a:p>
-        </p:txBody>
-      </p:sp>
-      <p:sp>
-        <p:nvSpPr>
-          <p:cNvPr id="41" name="TextBox 40"/>
-          <p:cNvSpPr txBox="1"/>
-          <p:nvPr/>
-        </p:nvSpPr>
-        <p:spPr>
-          <a:xfrm>
-            <a:off x="6336792" y="5166360"/>
-            <a:ext cx="1645920" cy="256032"/>
-          </a:xfrm>
-          <a:prstGeom prst="rect">
-            <a:avLst/>
-          </a:prstGeom>
-          <a:noFill/>
-        </p:spPr>
-        <p:txBody>
-          <a:bodyPr wrap="square">
-            <a:spAutoFit/>
-          </a:bodyPr>
-          <a:lstStyle/>
-          <a:p>
-            <a:pPr algn="l"/>
-            <a:r>
-              <a:rPr sz="1100" b="0">
-                <a:solidFill>
-                  <a:srgbClr val="4A4A4A"/>
-                </a:solidFill>
-                <a:latin typeface="Microsoft YaHei"/>
-                <a:ea typeface="Microsoft YaHei"/>
-              </a:rPr>
-              <a:t>DRAM 为主 → 分层</a:t>
-            </a:r>
-          </a:p>
-        </p:txBody>
-      </p:sp>
-      <p:sp>
-        <p:nvSpPr>
-          <p:cNvPr id="42" name="TextBox 41"/>
-          <p:cNvSpPr txBox="1"/>
-          <p:nvPr/>
-        </p:nvSpPr>
-        <p:spPr>
-          <a:xfrm>
-            <a:off x="6336792" y="5413248"/>
-            <a:ext cx="1645920" cy="292608"/>
-          </a:xfrm>
-          <a:prstGeom prst="rect">
-            <a:avLst/>
-          </a:prstGeom>
-          <a:noFill/>
-        </p:spPr>
-        <p:txBody>
-          <a:bodyPr wrap="square">
-            <a:spAutoFit/>
-          </a:bodyPr>
-          <a:lstStyle/>
-          <a:p>
-            <a:pPr algn="l"/>
-            <a:r>
-              <a:rPr sz="1800" b="1">
-                <a:solidFill>
-                  <a:srgbClr val="8B1A2B"/>
-                </a:solidFill>
-                <a:latin typeface="Microsoft YaHei"/>
-                <a:ea typeface="Microsoft YaHei"/>
-              </a:rPr>
-              <a:t>降幅&gt;80%*</a:t>
-            </a:r>
-          </a:p>
-        </p:txBody>
-      </p:sp>
-      <p:sp>
-        <p:nvSpPr>
-          <p:cNvPr id="43" name="Rectangle 42"/>
-          <p:cNvSpPr/>
-          <p:nvPr/>
-        </p:nvSpPr>
-        <p:spPr>
-          <a:xfrm>
-            <a:off x="8147304" y="4910328"/>
-            <a:ext cx="1847088" cy="868680"/>
-          </a:xfrm>
-          <a:prstGeom prst="rect">
-            <a:avLst/>
-          </a:prstGeom>
-          <a:solidFill>
-            <a:srgbClr val="FFFFFF"/>
-          </a:solidFill>
-          <a:ln w="12700">
-            <a:solidFill>
-              <a:srgbClr val="D0D8DE"/>
-            </a:solidFill>
-          </a:ln>
-        </p:spPr>
-        <p:style>
-          <a:lnRef idx="1">
-            <a:schemeClr val="accent1"/>
-          </a:lnRef>
-          <a:fillRef idx="3">
-            <a:schemeClr val="accent1"/>
-          </a:fillRef>
-          <a:effectRef idx="2">
-            <a:schemeClr val="accent1"/>
-          </a:effectRef>
-          <a:fontRef idx="minor">
-            <a:schemeClr val="lt1"/>
-          </a:fontRef>
-        </p:style>
-        <p:txBody>
-          <a:bodyPr rtlCol="0" anchor="ctr"/>
-          <a:lstStyle/>
-          <a:p>
-            <a:pPr algn="ctr"/>
-          </a:p>
-        </p:txBody>
-      </p:sp>
-      <p:sp>
-        <p:nvSpPr>
-          <p:cNvPr id="44" name="Rectangle 43"/>
-          <p:cNvSpPr/>
-          <p:nvPr/>
-        </p:nvSpPr>
-        <p:spPr>
-          <a:xfrm>
-            <a:off x="8147304" y="4910328"/>
-            <a:ext cx="50800" cy="868680"/>
-          </a:xfrm>
-          <a:prstGeom prst="rect">
-            <a:avLst/>
-          </a:prstGeom>
-          <a:solidFill>
-            <a:srgbClr val="8B1A2B"/>
-          </a:solidFill>
-          <a:ln>
-            <a:noFill/>
-          </a:ln>
-        </p:spPr>
-        <p:style>
-          <a:lnRef idx="1">
-            <a:schemeClr val="accent1"/>
-          </a:lnRef>
-          <a:fillRef idx="3">
-            <a:schemeClr val="accent1"/>
-          </a:fillRef>
-          <a:effectRef idx="2">
-            <a:schemeClr val="accent1"/>
-          </a:effectRef>
-          <a:fontRef idx="minor">
-            <a:schemeClr val="lt1"/>
-          </a:fontRef>
-        </p:style>
-        <p:txBody>
-          <a:bodyPr rtlCol="0" anchor="ctr"/>
-          <a:lstStyle/>
-          <a:p>
-            <a:pPr algn="ctr"/>
-          </a:p>
-        </p:txBody>
-      </p:sp>
-      <p:sp>
-        <p:nvSpPr>
-          <p:cNvPr id="45" name="TextBox 44"/>
-          <p:cNvSpPr txBox="1"/>
-          <p:nvPr/>
-        </p:nvSpPr>
-        <p:spPr>
-          <a:xfrm>
-            <a:off x="8293608" y="4965192"/>
-            <a:ext cx="1645920" cy="201168"/>
-          </a:xfrm>
-          <a:prstGeom prst="rect">
-            <a:avLst/>
-          </a:prstGeom>
-          <a:noFill/>
-        </p:spPr>
-        <p:txBody>
-          <a:bodyPr wrap="square">
-            <a:spAutoFit/>
-          </a:bodyPr>
-          <a:lstStyle/>
-          <a:p>
-            <a:pPr algn="l"/>
-            <a:r>
-              <a:rPr sz="1100" b="0">
-                <a:solidFill>
-                  <a:srgbClr val="6B6B6B"/>
-                </a:solidFill>
-                <a:latin typeface="Microsoft YaHei"/>
-                <a:ea typeface="Microsoft YaHei"/>
-              </a:rPr>
-              <a:t>HiSim 误差</a:t>
-            </a:r>
-          </a:p>
-        </p:txBody>
-      </p:sp>
-      <p:sp>
-        <p:nvSpPr>
-          <p:cNvPr id="46" name="TextBox 45"/>
-          <p:cNvSpPr txBox="1"/>
-          <p:nvPr/>
-        </p:nvSpPr>
-        <p:spPr>
-          <a:xfrm>
-            <a:off x="8293608" y="5166360"/>
-            <a:ext cx="1645920" cy="256032"/>
-          </a:xfrm>
-          <a:prstGeom prst="rect">
-            <a:avLst/>
-          </a:prstGeom>
-          <a:noFill/>
-        </p:spPr>
-        <p:txBody>
-          <a:bodyPr wrap="square">
-            <a:spAutoFit/>
-          </a:bodyPr>
-          <a:lstStyle/>
-          <a:p>
-            <a:pPr algn="l"/>
-            <a:r>
-              <a:rPr sz="1100" b="0">
-                <a:solidFill>
-                  <a:srgbClr val="4A4A4A"/>
-                </a:solidFill>
-                <a:latin typeface="Microsoft YaHei"/>
-                <a:ea typeface="Microsoft YaHei"/>
-              </a:rPr>
-              <a:t>经验配置 → 仿真</a:t>
-            </a:r>
-          </a:p>
-        </p:txBody>
-      </p:sp>
-      <p:sp>
-        <p:nvSpPr>
-          <p:cNvPr id="47" name="TextBox 46"/>
-          <p:cNvSpPr txBox="1"/>
-          <p:nvPr/>
-        </p:nvSpPr>
-        <p:spPr>
-          <a:xfrm>
-            <a:off x="8293608" y="5413248"/>
-            <a:ext cx="1645920" cy="292608"/>
-          </a:xfrm>
-          <a:prstGeom prst="rect">
-            <a:avLst/>
-          </a:prstGeom>
-          <a:noFill/>
-        </p:spPr>
-        <p:txBody>
-          <a:bodyPr wrap="square">
-            <a:spAutoFit/>
-          </a:bodyPr>
-          <a:lstStyle/>
-          <a:p>
-            <a:pPr algn="l"/>
-            <a:r>
-              <a:rPr sz="1800" b="1">
-                <a:solidFill>
-                  <a:srgbClr val="8B1A2B"/>
-                </a:solidFill>
-                <a:latin typeface="Microsoft YaHei"/>
-                <a:ea typeface="Microsoft YaHei"/>
-              </a:rPr>
-              <a:t>&lt;3%*</a:t>
-            </a:r>
-          </a:p>
-        </p:txBody>
-      </p:sp>
-      <p:sp>
-        <p:nvSpPr>
-          <p:cNvPr id="48" name="Rectangle 47"/>
-          <p:cNvSpPr/>
-          <p:nvPr/>
-        </p:nvSpPr>
-        <p:spPr>
-          <a:xfrm>
-            <a:off x="10104120" y="4910328"/>
-            <a:ext cx="1847088" cy="868680"/>
-          </a:xfrm>
-          <a:prstGeom prst="rect">
-            <a:avLst/>
-          </a:prstGeom>
-          <a:solidFill>
-            <a:srgbClr val="FFFFFF"/>
-          </a:solidFill>
-          <a:ln w="12700">
-            <a:solidFill>
-              <a:srgbClr val="D0D8DE"/>
-            </a:solidFill>
-          </a:ln>
-        </p:spPr>
-        <p:style>
-          <a:lnRef idx="1">
-            <a:schemeClr val="accent1"/>
-          </a:lnRef>
-          <a:fillRef idx="3">
-            <a:schemeClr val="accent1"/>
-          </a:fillRef>
-          <a:effectRef idx="2">
-            <a:schemeClr val="accent1"/>
-          </a:effectRef>
-          <a:fontRef idx="minor">
-            <a:schemeClr val="lt1"/>
-          </a:fontRef>
-        </p:style>
-        <p:txBody>
-          <a:bodyPr rtlCol="0" anchor="ctr"/>
-          <a:lstStyle/>
-          <a:p>
-            <a:pPr algn="ctr"/>
-          </a:p>
-        </p:txBody>
-      </p:sp>
-      <p:sp>
-        <p:nvSpPr>
-          <p:cNvPr id="49" name="Rectangle 48"/>
-          <p:cNvSpPr/>
-          <p:nvPr/>
-        </p:nvSpPr>
-        <p:spPr>
-          <a:xfrm>
-            <a:off x="10104120" y="4910328"/>
-            <a:ext cx="50800" cy="868680"/>
-          </a:xfrm>
-          <a:prstGeom prst="rect">
-            <a:avLst/>
-          </a:prstGeom>
-          <a:solidFill>
-            <a:srgbClr val="8B1A2B"/>
-          </a:solidFill>
-          <a:ln>
-            <a:noFill/>
-          </a:ln>
-        </p:spPr>
-        <p:style>
-          <a:lnRef idx="1">
-            <a:schemeClr val="accent1"/>
-          </a:lnRef>
-          <a:fillRef idx="3">
-            <a:schemeClr val="accent1"/>
-          </a:fillRef>
-          <a:effectRef idx="2">
-            <a:schemeClr val="accent1"/>
-          </a:effectRef>
-          <a:fontRef idx="minor">
-            <a:schemeClr val="lt1"/>
-          </a:fontRef>
-        </p:style>
-        <p:txBody>
-          <a:bodyPr rtlCol="0" anchor="ctr"/>
-          <a:lstStyle/>
-          <a:p>
-            <a:pPr algn="ctr"/>
-          </a:p>
-        </p:txBody>
-      </p:sp>
-      <p:sp>
-        <p:nvSpPr>
-          <p:cNvPr id="50" name="TextBox 49"/>
-          <p:cNvSpPr txBox="1"/>
-          <p:nvPr/>
-        </p:nvSpPr>
-        <p:spPr>
-          <a:xfrm>
-            <a:off x="10250424" y="4965192"/>
-            <a:ext cx="1645920" cy="201168"/>
-          </a:xfrm>
-          <a:prstGeom prst="rect">
-            <a:avLst/>
-          </a:prstGeom>
-          <a:noFill/>
-        </p:spPr>
-        <p:txBody>
-          <a:bodyPr wrap="square">
-            <a:spAutoFit/>
-          </a:bodyPr>
-          <a:lstStyle/>
-          <a:p>
-            <a:pPr algn="l"/>
-            <a:r>
-              <a:rPr sz="1100" b="0">
-                <a:solidFill>
-                  <a:srgbClr val="6B6B6B"/>
-                </a:solidFill>
-                <a:latin typeface="Microsoft YaHei"/>
-                <a:ea typeface="Microsoft YaHei"/>
-              </a:rPr>
-              <a:t>分层形态</a:t>
-            </a:r>
-          </a:p>
-        </p:txBody>
-      </p:sp>
-      <p:sp>
-        <p:nvSpPr>
-          <p:cNvPr id="51" name="TextBox 50"/>
-          <p:cNvSpPr txBox="1"/>
-          <p:nvPr/>
-        </p:nvSpPr>
-        <p:spPr>
-          <a:xfrm>
-            <a:off x="10250424" y="5166360"/>
-            <a:ext cx="1645920" cy="256032"/>
-          </a:xfrm>
-          <a:prstGeom prst="rect">
-            <a:avLst/>
-          </a:prstGeom>
-          <a:noFill/>
-        </p:spPr>
-        <p:txBody>
-          <a:bodyPr wrap="square">
-            <a:spAutoFit/>
-          </a:bodyPr>
-          <a:lstStyle/>
-          <a:p>
-            <a:pPr algn="l"/>
-            <a:r>
-              <a:rPr sz="1100" b="0">
-                <a:solidFill>
-                  <a:srgbClr val="4A4A4A"/>
-                </a:solidFill>
-                <a:latin typeface="Microsoft YaHei"/>
-                <a:ea typeface="Microsoft YaHei"/>
-              </a:rPr>
-              <a:t>单机 HBM</a:t>
-            </a:r>
-          </a:p>
-        </p:txBody>
-      </p:sp>
-      <p:sp>
-        <p:nvSpPr>
-          <p:cNvPr id="52" name="TextBox 51"/>
-          <p:cNvSpPr txBox="1"/>
-          <p:nvPr/>
-        </p:nvSpPr>
-        <p:spPr>
-          <a:xfrm>
-            <a:off x="10250424" y="5413248"/>
-            <a:ext cx="1645920" cy="292608"/>
-          </a:xfrm>
-          <a:prstGeom prst="rect">
-            <a:avLst/>
-          </a:prstGeom>
-          <a:noFill/>
-        </p:spPr>
-        <p:txBody>
-          <a:bodyPr wrap="square">
-            <a:spAutoFit/>
-          </a:bodyPr>
-          <a:lstStyle/>
-          <a:p>
-            <a:pPr algn="l"/>
-            <a:r>
-              <a:rPr sz="1800" b="1">
-                <a:solidFill>
-                  <a:srgbClr val="8B1A2B"/>
-                </a:solidFill>
-                <a:latin typeface="Microsoft YaHei"/>
-                <a:ea typeface="Microsoft YaHei"/>
-              </a:rPr>
-              <a:t>G1–G4 栈</a:t>
-            </a:r>
-          </a:p>
-        </p:txBody>
-      </p:sp>
-      <p:sp>
-        <p:nvSpPr>
-          <p:cNvPr id="53" name="Rectangle 52"/>
-          <p:cNvSpPr/>
-          <p:nvPr/>
-        </p:nvSpPr>
-        <p:spPr>
-          <a:xfrm>
-            <a:off x="0" y="5989320"/>
-            <a:ext cx="12191695" cy="868680"/>
-          </a:xfrm>
-          <a:prstGeom prst="rect">
-            <a:avLst/>
-          </a:prstGeom>
-          <a:solidFill>
-            <a:srgbClr val="FFFFFF"/>
-          </a:solidFill>
-          <a:ln>
-            <a:noFill/>
-          </a:ln>
-        </p:spPr>
-        <p:style>
-          <a:lnRef idx="1">
-            <a:schemeClr val="accent1"/>
-          </a:lnRef>
-          <a:fillRef idx="3">
-            <a:schemeClr val="accent1"/>
-          </a:fillRef>
-          <a:effectRef idx="2">
-            <a:schemeClr val="accent1"/>
-          </a:effectRef>
-          <a:fontRef idx="minor">
-            <a:schemeClr val="lt1"/>
-          </a:fontRef>
-        </p:style>
-        <p:txBody>
-          <a:bodyPr rtlCol="0" anchor="ctr"/>
-          <a:lstStyle/>
-          <a:p>
-            <a:pPr algn="ctr"/>
-          </a:p>
-        </p:txBody>
-      </p:sp>
-      <p:sp>
-        <p:nvSpPr>
-          <p:cNvPr id="54" name="Rectangle 53"/>
-          <p:cNvSpPr/>
-          <p:nvPr/>
-        </p:nvSpPr>
-        <p:spPr>
-          <a:xfrm>
-            <a:off x="0" y="5989320"/>
-            <a:ext cx="12191695" cy="25400"/>
-          </a:xfrm>
-          <a:prstGeom prst="rect">
-            <a:avLst/>
-          </a:prstGeom>
-          <a:solidFill>
-            <a:srgbClr val="8B1A2B"/>
-          </a:solidFill>
-          <a:ln>
-            <a:noFill/>
-          </a:ln>
-        </p:spPr>
-        <p:style>
-          <a:lnRef idx="1">
-            <a:schemeClr val="accent1"/>
-          </a:lnRef>
-          <a:fillRef idx="3">
-            <a:schemeClr val="accent1"/>
-          </a:fillRef>
-          <a:effectRef idx="2">
-            <a:schemeClr val="accent1"/>
-          </a:effectRef>
-          <a:fontRef idx="minor">
-            <a:schemeClr val="lt1"/>
-          </a:fontRef>
-        </p:style>
-        <p:txBody>
-          <a:bodyPr rtlCol="0" anchor="ctr"/>
-          <a:lstStyle/>
-          <a:p>
-            <a:pPr algn="ctr"/>
-          </a:p>
-        </p:txBody>
-      </p:sp>
-      <p:sp>
-        <p:nvSpPr>
-          <p:cNvPr id="55" name="TextBox 54"/>
-          <p:cNvSpPr txBox="1"/>
-          <p:nvPr/>
-        </p:nvSpPr>
-        <p:spPr>
-          <a:xfrm>
-            <a:off x="365760" y="6080760"/>
-            <a:ext cx="11430000" cy="256032"/>
-          </a:xfrm>
-          <a:prstGeom prst="rect">
-            <a:avLst/>
-          </a:prstGeom>
-          <a:noFill/>
-        </p:spPr>
-        <p:txBody>
-          <a:bodyPr wrap="square">
-            <a:spAutoFit/>
-          </a:bodyPr>
-          <a:lstStyle/>
-          <a:p>
-            <a:pPr algn="l"/>
-            <a:r>
               <a:rPr sz="1200" b="1">
                 <a:solidFill>
                   <a:srgbClr val="1A1A1A"/>
@@ -5445,7 +4929,7 @@
       </p:sp>
       <p:sp>
         <p:nvSpPr>
-          <p:cNvPr id="56" name="TextBox 55"/>
+          <p:cNvPr id="44" name="TextBox 43"/>
           <p:cNvSpPr txBox="1"/>
           <p:nvPr/>
         </p:nvSpPr>

</xml_diff>

<commit_message>
Add data screenshot evidence pages to insight PPTs
Each one-pager now has a second slide with cropped official replay
slides backing the key metrics (KVCache, fullstack, future, forum).

Co-authored-by: Annie <Annie-Summer@users.noreply.github.com>
</commit_message>
<xml_diff>
--- a/yunqi-2026-cipu-forum/docs/洞察一页-04-KVCache推理基础设施.pptx
+++ b/yunqi-2026-cipu-forum/docs/洞察一页-04-KVCache推理基础设施.pptx
@@ -6,6 +6,7 @@
   </p:sldMasterIdLst>
   <p:sldIdLst>
     <p:sldId id="256" r:id="rId7"/>
+    <p:sldId id="257" r:id="rId8"/>
   </p:sldIdLst>
   <p:sldSz cx="12191695" cy="6858000" type="screen4x3"/>
   <p:notesSz cx="6858000" cy="9144000"/>
@@ -4959,6 +4960,641 @@
                 <a:ea typeface="Microsoft YaHei"/>
               </a:rPr>
               <a:t>*为演讲幻灯宣称口径  ·  来源：云栖大会 agendaId=164 · Talk 04 王正恒 / 徐国强</a:t>
+            </a:r>
+          </a:p>
+        </p:txBody>
+      </p:sp>
+    </p:spTree>
+  </p:cSld>
+  <p:clrMapOvr>
+    <a:masterClrMapping/>
+  </p:clrMapOvr>
+</p:sld>
+</file>
+
+<file path=ppt/slides/slide2.xml><?xml version="1.0" encoding="utf-8"?>
+<p:sld xmlns:a="http://schemas.openxmlformats.org/drawingml/2006/main" xmlns:p="http://schemas.openxmlformats.org/presentationml/2006/main" xmlns:r="http://schemas.openxmlformats.org/officeDocument/2006/relationships">
+  <p:cSld>
+    <p:spTree>
+      <p:nvGrpSpPr>
+        <p:cNvPr id="1" name=""/>
+        <p:cNvGrpSpPr/>
+        <p:nvPr/>
+      </p:nvGrpSpPr>
+      <p:grpSpPr/>
+      <p:sp>
+        <p:nvSpPr>
+          <p:cNvPr id="2" name="Rectangle 1"/>
+          <p:cNvSpPr/>
+          <p:nvPr/>
+        </p:nvSpPr>
+        <p:spPr>
+          <a:xfrm>
+            <a:off x="0" y="0"/>
+            <a:ext cx="12191695" cy="6858000"/>
+          </a:xfrm>
+          <a:prstGeom prst="rect">
+            <a:avLst/>
+          </a:prstGeom>
+          <a:solidFill>
+            <a:srgbClr val="F5F7F9"/>
+          </a:solidFill>
+          <a:ln>
+            <a:noFill/>
+          </a:ln>
+        </p:spPr>
+        <p:style>
+          <a:lnRef idx="1">
+            <a:schemeClr val="accent1"/>
+          </a:lnRef>
+          <a:fillRef idx="3">
+            <a:schemeClr val="accent1"/>
+          </a:fillRef>
+          <a:effectRef idx="2">
+            <a:schemeClr val="accent1"/>
+          </a:effectRef>
+          <a:fontRef idx="minor">
+            <a:schemeClr val="lt1"/>
+          </a:fontRef>
+        </p:style>
+        <p:txBody>
+          <a:bodyPr rtlCol="0" anchor="ctr"/>
+          <a:lstStyle/>
+          <a:p>
+            <a:pPr algn="ctr"/>
+          </a:p>
+        </p:txBody>
+      </p:sp>
+      <p:sp>
+        <p:nvSpPr>
+          <p:cNvPr id="3" name="Rectangle 2"/>
+          <p:cNvSpPr/>
+          <p:nvPr/>
+        </p:nvSpPr>
+        <p:spPr>
+          <a:xfrm>
+            <a:off x="0" y="0"/>
+            <a:ext cx="12191695" cy="868680"/>
+          </a:xfrm>
+          <a:prstGeom prst="rect">
+            <a:avLst/>
+          </a:prstGeom>
+          <a:solidFill>
+            <a:srgbClr val="FFFFFF"/>
+          </a:solidFill>
+          <a:ln>
+            <a:noFill/>
+          </a:ln>
+        </p:spPr>
+        <p:style>
+          <a:lnRef idx="1">
+            <a:schemeClr val="accent1"/>
+          </a:lnRef>
+          <a:fillRef idx="3">
+            <a:schemeClr val="accent1"/>
+          </a:fillRef>
+          <a:effectRef idx="2">
+            <a:schemeClr val="accent1"/>
+          </a:effectRef>
+          <a:fontRef idx="minor">
+            <a:schemeClr val="lt1"/>
+          </a:fontRef>
+        </p:style>
+        <p:txBody>
+          <a:bodyPr rtlCol="0" anchor="ctr"/>
+          <a:lstStyle/>
+          <a:p>
+            <a:pPr algn="ctr"/>
+          </a:p>
+        </p:txBody>
+      </p:sp>
+      <p:sp>
+        <p:nvSpPr>
+          <p:cNvPr id="4" name="TextBox 3"/>
+          <p:cNvSpPr txBox="1"/>
+          <p:nvPr/>
+        </p:nvSpPr>
+        <p:spPr>
+          <a:xfrm>
+            <a:off x="365760" y="146304"/>
+            <a:ext cx="11430000" cy="256032"/>
+          </a:xfrm>
+          <a:prstGeom prst="rect">
+            <a:avLst/>
+          </a:prstGeom>
+          <a:noFill/>
+        </p:spPr>
+        <p:txBody>
+          <a:bodyPr wrap="square">
+            <a:spAutoFit/>
+          </a:bodyPr>
+          <a:lstStyle/>
+          <a:p>
+            <a:pPr algn="l"/>
+            <a:r>
+              <a:rPr sz="1200" b="0">
+                <a:solidFill>
+                  <a:srgbClr val="6B6B6B"/>
+                </a:solidFill>
+                <a:latin typeface="Microsoft YaHei"/>
+                <a:ea typeface="Microsoft YaHei"/>
+              </a:rPr>
+              <a:t>04 · 王正恒 / 徐国强 · KVCache：从显存优化到软硬结合的推理基础设施</a:t>
+            </a:r>
+          </a:p>
+        </p:txBody>
+      </p:sp>
+      <p:sp>
+        <p:nvSpPr>
+          <p:cNvPr id="5" name="TextBox 4"/>
+          <p:cNvSpPr txBox="1"/>
+          <p:nvPr/>
+        </p:nvSpPr>
+        <p:spPr>
+          <a:xfrm>
+            <a:off x="365760" y="384048"/>
+            <a:ext cx="11430000" cy="365760"/>
+          </a:xfrm>
+          <a:prstGeom prst="rect">
+            <a:avLst/>
+          </a:prstGeom>
+          <a:noFill/>
+        </p:spPr>
+        <p:txBody>
+          <a:bodyPr wrap="square">
+            <a:spAutoFit/>
+          </a:bodyPr>
+          <a:lstStyle/>
+          <a:p>
+            <a:pPr algn="l"/>
+            <a:r>
+              <a:rPr sz="2200" b="1">
+                <a:solidFill>
+                  <a:srgbClr val="1A1A1A"/>
+                </a:solidFill>
+                <a:latin typeface="Microsoft YaHei"/>
+                <a:ea typeface="Microsoft YaHei"/>
+              </a:rPr>
+              <a:t>数据佐证｜官方回放截图</a:t>
+            </a:r>
+          </a:p>
+        </p:txBody>
+      </p:sp>
+      <p:sp>
+        <p:nvSpPr>
+          <p:cNvPr id="6" name="Rectangle 5"/>
+          <p:cNvSpPr/>
+          <p:nvPr/>
+        </p:nvSpPr>
+        <p:spPr>
+          <a:xfrm>
+            <a:off x="320040" y="1051560"/>
+            <a:ext cx="3716426" cy="5074920"/>
+          </a:xfrm>
+          <a:prstGeom prst="rect">
+            <a:avLst/>
+          </a:prstGeom>
+          <a:solidFill>
+            <a:srgbClr val="FFFFFF"/>
+          </a:solidFill>
+          <a:ln w="12700">
+            <a:solidFill>
+              <a:srgbClr val="D0D8DE"/>
+            </a:solidFill>
+          </a:ln>
+        </p:spPr>
+        <p:style>
+          <a:lnRef idx="1">
+            <a:schemeClr val="accent1"/>
+          </a:lnRef>
+          <a:fillRef idx="3">
+            <a:schemeClr val="accent1"/>
+          </a:fillRef>
+          <a:effectRef idx="2">
+            <a:schemeClr val="accent1"/>
+          </a:effectRef>
+          <a:fontRef idx="minor">
+            <a:schemeClr val="lt1"/>
+          </a:fontRef>
+        </p:style>
+        <p:txBody>
+          <a:bodyPr rtlCol="0" anchor="ctr"/>
+          <a:lstStyle/>
+          <a:p>
+            <a:pPr algn="ctr"/>
+          </a:p>
+        </p:txBody>
+      </p:sp>
+      <p:sp>
+        <p:nvSpPr>
+          <p:cNvPr id="7" name="TextBox 6"/>
+          <p:cNvSpPr txBox="1"/>
+          <p:nvPr/>
+        </p:nvSpPr>
+        <p:spPr>
+          <a:xfrm>
+            <a:off x="429768" y="1143000"/>
+            <a:ext cx="3496970" cy="292608"/>
+          </a:xfrm>
+          <a:prstGeom prst="rect">
+            <a:avLst/>
+          </a:prstGeom>
+          <a:noFill/>
+        </p:spPr>
+        <p:txBody>
+          <a:bodyPr wrap="square">
+            <a:spAutoFit/>
+          </a:bodyPr>
+          <a:lstStyle/>
+          <a:p>
+            <a:pPr algn="l"/>
+            <a:r>
+              <a:rPr sz="1300" b="1">
+                <a:solidFill>
+                  <a:srgbClr val="8B1A2B"/>
+                </a:solidFill>
+                <a:latin typeface="Microsoft YaHei"/>
+                <a:ea typeface="Microsoft YaHei"/>
+              </a:rPr>
+              <a:t>吞吐 +50%+ · TTFT -30% · 传输 93%+</a:t>
+            </a:r>
+          </a:p>
+        </p:txBody>
+      </p:sp>
+      <p:pic>
+        <p:nvPicPr>
+          <p:cNvPr id="8" name="Picture 7" descr="04-mempool-metrics.png"/>
+          <p:cNvPicPr>
+            <a:picLocks noChangeAspect="1"/>
+          </p:cNvPicPr>
+          <p:nvPr/>
+        </p:nvPicPr>
+        <p:blipFill>
+          <a:blip r:embed="rId2"/>
+          <a:stretch>
+            <a:fillRect/>
+          </a:stretch>
+        </p:blipFill>
+        <p:spPr>
+          <a:xfrm>
+            <a:off x="429768" y="2153925"/>
+            <a:ext cx="3496970" cy="2513574"/>
+          </a:xfrm>
+          <a:prstGeom prst="rect">
+            <a:avLst/>
+          </a:prstGeom>
+        </p:spPr>
+      </p:pic>
+      <p:sp>
+        <p:nvSpPr>
+          <p:cNvPr id="9" name="TextBox 8"/>
+          <p:cNvSpPr txBox="1"/>
+          <p:nvPr/>
+        </p:nvSpPr>
+        <p:spPr>
+          <a:xfrm>
+            <a:off x="429768" y="5486400"/>
+            <a:ext cx="3496970" cy="502920"/>
+          </a:xfrm>
+          <a:prstGeom prst="rect">
+            <a:avLst/>
+          </a:prstGeom>
+          <a:noFill/>
+        </p:spPr>
+        <p:txBody>
+          <a:bodyPr wrap="square">
+            <a:spAutoFit/>
+          </a:bodyPr>
+          <a:lstStyle/>
+          <a:p>
+            <a:pPr algn="l"/>
+            <a:r>
+              <a:rPr sz="1100" b="0">
+                <a:solidFill>
+                  <a:srgbClr val="4A4A4A"/>
+                </a:solidFill>
+                <a:latin typeface="Microsoft YaHei"/>
+                <a:ea typeface="Microsoft YaHei"/>
+              </a:rPr>
+              <a:t>Tair Memory Pool 客户场景实测（回放截图）</a:t>
+            </a:r>
+          </a:p>
+        </p:txBody>
+      </p:sp>
+      <p:sp>
+        <p:nvSpPr>
+          <p:cNvPr id="10" name="Rectangle 9"/>
+          <p:cNvSpPr/>
+          <p:nvPr/>
+        </p:nvSpPr>
+        <p:spPr>
+          <a:xfrm>
+            <a:off x="4237634" y="1051560"/>
+            <a:ext cx="3716426" cy="5074920"/>
+          </a:xfrm>
+          <a:prstGeom prst="rect">
+            <a:avLst/>
+          </a:prstGeom>
+          <a:solidFill>
+            <a:srgbClr val="FFFFFF"/>
+          </a:solidFill>
+          <a:ln w="12700">
+            <a:solidFill>
+              <a:srgbClr val="D0D8DE"/>
+            </a:solidFill>
+          </a:ln>
+        </p:spPr>
+        <p:style>
+          <a:lnRef idx="1">
+            <a:schemeClr val="accent1"/>
+          </a:lnRef>
+          <a:fillRef idx="3">
+            <a:schemeClr val="accent1"/>
+          </a:fillRef>
+          <a:effectRef idx="2">
+            <a:schemeClr val="accent1"/>
+          </a:effectRef>
+          <a:fontRef idx="minor">
+            <a:schemeClr val="lt1"/>
+          </a:fontRef>
+        </p:style>
+        <p:txBody>
+          <a:bodyPr rtlCol="0" anchor="ctr"/>
+          <a:lstStyle/>
+          <a:p>
+            <a:pPr algn="ctr"/>
+          </a:p>
+        </p:txBody>
+      </p:sp>
+      <p:sp>
+        <p:nvSpPr>
+          <p:cNvPr id="11" name="TextBox 10"/>
+          <p:cNvSpPr txBox="1"/>
+          <p:nvPr/>
+        </p:nvSpPr>
+        <p:spPr>
+          <a:xfrm>
+            <a:off x="4347362" y="1143000"/>
+            <a:ext cx="3496970" cy="292608"/>
+          </a:xfrm>
+          <a:prstGeom prst="rect">
+            <a:avLst/>
+          </a:prstGeom>
+          <a:noFill/>
+        </p:spPr>
+        <p:txBody>
+          <a:bodyPr wrap="square">
+            <a:spAutoFit/>
+          </a:bodyPr>
+          <a:lstStyle/>
+          <a:p>
+            <a:pPr algn="l"/>
+            <a:r>
+              <a:rPr sz="1300" b="1">
+                <a:solidFill>
+                  <a:srgbClr val="8B1A2B"/>
+                </a:solidFill>
+                <a:latin typeface="Microsoft YaHei"/>
+                <a:ea typeface="Microsoft YaHei"/>
+              </a:rPr>
+              <a:t>G1–G4 分层带宽/时延/容量表</a:t>
+            </a:r>
+          </a:p>
+        </p:txBody>
+      </p:sp>
+      <p:pic>
+        <p:nvPicPr>
+          <p:cNvPr id="12" name="Picture 11" descr="04-tier-table.png"/>
+          <p:cNvPicPr>
+            <a:picLocks noChangeAspect="1"/>
+          </p:cNvPicPr>
+          <p:nvPr/>
+        </p:nvPicPr>
+        <p:blipFill>
+          <a:blip r:embed="rId3"/>
+          <a:stretch>
+            <a:fillRect/>
+          </a:stretch>
+        </p:blipFill>
+        <p:spPr>
+          <a:xfrm>
+            <a:off x="4347362" y="2153925"/>
+            <a:ext cx="3496970" cy="2513574"/>
+          </a:xfrm>
+          <a:prstGeom prst="rect">
+            <a:avLst/>
+          </a:prstGeom>
+        </p:spPr>
+      </p:pic>
+      <p:sp>
+        <p:nvSpPr>
+          <p:cNvPr id="13" name="TextBox 12"/>
+          <p:cNvSpPr txBox="1"/>
+          <p:nvPr/>
+        </p:nvSpPr>
+        <p:spPr>
+          <a:xfrm>
+            <a:off x="4347362" y="5486400"/>
+            <a:ext cx="3496970" cy="502920"/>
+          </a:xfrm>
+          <a:prstGeom prst="rect">
+            <a:avLst/>
+          </a:prstGeom>
+          <a:noFill/>
+        </p:spPr>
+        <p:txBody>
+          <a:bodyPr wrap="square">
+            <a:spAutoFit/>
+          </a:bodyPr>
+          <a:lstStyle/>
+          <a:p>
+            <a:pPr algn="l"/>
+            <a:r>
+              <a:rPr sz="1100" b="0">
+                <a:solidFill>
+                  <a:srgbClr val="4A4A4A"/>
+                </a:solidFill>
+                <a:latin typeface="Microsoft YaHei"/>
+                <a:ea typeface="Microsoft YaHei"/>
+              </a:rPr>
+              <a:t>KVCache 分层存储定义与技术方向</a:t>
+            </a:r>
+          </a:p>
+        </p:txBody>
+      </p:sp>
+      <p:sp>
+        <p:nvSpPr>
+          <p:cNvPr id="14" name="Rectangle 13"/>
+          <p:cNvSpPr/>
+          <p:nvPr/>
+        </p:nvSpPr>
+        <p:spPr>
+          <a:xfrm>
+            <a:off x="8155228" y="1051560"/>
+            <a:ext cx="3716426" cy="5074920"/>
+          </a:xfrm>
+          <a:prstGeom prst="rect">
+            <a:avLst/>
+          </a:prstGeom>
+          <a:solidFill>
+            <a:srgbClr val="FFFFFF"/>
+          </a:solidFill>
+          <a:ln w="12700">
+            <a:solidFill>
+              <a:srgbClr val="D0D8DE"/>
+            </a:solidFill>
+          </a:ln>
+        </p:spPr>
+        <p:style>
+          <a:lnRef idx="1">
+            <a:schemeClr val="accent1"/>
+          </a:lnRef>
+          <a:fillRef idx="3">
+            <a:schemeClr val="accent1"/>
+          </a:fillRef>
+          <a:effectRef idx="2">
+            <a:schemeClr val="accent1"/>
+          </a:effectRef>
+          <a:fontRef idx="minor">
+            <a:schemeClr val="lt1"/>
+          </a:fontRef>
+        </p:style>
+        <p:txBody>
+          <a:bodyPr rtlCol="0" anchor="ctr"/>
+          <a:lstStyle/>
+          <a:p>
+            <a:pPr algn="ctr"/>
+          </a:p>
+        </p:txBody>
+      </p:sp>
+      <p:sp>
+        <p:nvSpPr>
+          <p:cNvPr id="15" name="TextBox 14"/>
+          <p:cNvSpPr txBox="1"/>
+          <p:nvPr/>
+        </p:nvSpPr>
+        <p:spPr>
+          <a:xfrm>
+            <a:off x="8264956" y="1143000"/>
+            <a:ext cx="3496970" cy="292608"/>
+          </a:xfrm>
+          <a:prstGeom prst="rect">
+            <a:avLst/>
+          </a:prstGeom>
+          <a:noFill/>
+        </p:spPr>
+        <p:txBody>
+          <a:bodyPr wrap="square">
+            <a:spAutoFit/>
+          </a:bodyPr>
+          <a:lstStyle/>
+          <a:p>
+            <a:pPr algn="l"/>
+            <a:r>
+              <a:rPr sz="1300" b="1">
+                <a:solidFill>
+                  <a:srgbClr val="8B1A2B"/>
+                </a:solidFill>
+                <a:latin typeface="Microsoft YaHei"/>
+                <a:ea typeface="Microsoft YaHei"/>
+              </a:rPr>
+              <a:t>介质五需求 · Token TCO 可测降幅</a:t>
+            </a:r>
+          </a:p>
+        </p:txBody>
+      </p:sp>
+      <p:pic>
+        <p:nvPicPr>
+          <p:cNvPr id="16" name="Picture 15" descr="04-storage-needs.png"/>
+          <p:cNvPicPr>
+            <a:picLocks noChangeAspect="1"/>
+          </p:cNvPicPr>
+          <p:nvPr/>
+        </p:nvPicPr>
+        <p:blipFill>
+          <a:blip r:embed="rId4"/>
+          <a:stretch>
+            <a:fillRect/>
+          </a:stretch>
+        </p:blipFill>
+        <p:spPr>
+          <a:xfrm>
+            <a:off x="8264956" y="2153925"/>
+            <a:ext cx="3496970" cy="2513574"/>
+          </a:xfrm>
+          <a:prstGeom prst="rect">
+            <a:avLst/>
+          </a:prstGeom>
+        </p:spPr>
+      </p:pic>
+      <p:sp>
+        <p:nvSpPr>
+          <p:cNvPr id="17" name="TextBox 16"/>
+          <p:cNvSpPr txBox="1"/>
+          <p:nvPr/>
+        </p:nvSpPr>
+        <p:spPr>
+          <a:xfrm>
+            <a:off x="8264956" y="5486400"/>
+            <a:ext cx="3496970" cy="502920"/>
+          </a:xfrm>
+          <a:prstGeom prst="rect">
+            <a:avLst/>
+          </a:prstGeom>
+          <a:noFill/>
+        </p:spPr>
+        <p:txBody>
+          <a:bodyPr wrap="square">
+            <a:spAutoFit/>
+          </a:bodyPr>
+          <a:lstStyle/>
+          <a:p>
+            <a:pPr algn="l"/>
+            <a:r>
+              <a:rPr sz="1100" b="0">
+                <a:solidFill>
+                  <a:srgbClr val="4A4A4A"/>
+                </a:solidFill>
+                <a:latin typeface="Microsoft YaHei"/>
+                <a:ea typeface="Microsoft YaHei"/>
+              </a:rPr>
+              <a:t>KVCache 对存储介质的关键诉求</a:t>
+            </a:r>
+          </a:p>
+        </p:txBody>
+      </p:sp>
+      <p:sp>
+        <p:nvSpPr>
+          <p:cNvPr id="18" name="TextBox 17"/>
+          <p:cNvSpPr txBox="1"/>
+          <p:nvPr/>
+        </p:nvSpPr>
+        <p:spPr>
+          <a:xfrm>
+            <a:off x="365760" y="6355080"/>
+            <a:ext cx="11430000" cy="274320"/>
+          </a:xfrm>
+          <a:prstGeom prst="rect">
+            <a:avLst/>
+          </a:prstGeom>
+          <a:noFill/>
+        </p:spPr>
+        <p:txBody>
+          <a:bodyPr wrap="square">
+            <a:spAutoFit/>
+          </a:bodyPr>
+          <a:lstStyle/>
+          <a:p>
+            <a:pPr algn="l"/>
+            <a:r>
+              <a:rPr sz="1000" b="0">
+                <a:solidFill>
+                  <a:srgbClr val="6B6B6B"/>
+                </a:solidFill>
+                <a:latin typeface="Microsoft YaHei"/>
+                <a:ea typeface="Microsoft YaHei"/>
+              </a:rPr>
+              <a:t>截图裁自云栖大会官方回放幻灯主体，作指标与结论佐证。</a:t>
             </a:r>
           </a:p>
         </p:txBody>

</xml_diff>